<commit_message>
docs: simplify team deck demo slide
</commit_message>
<xml_diff>
--- a/deliverables/JanaMen_DigitalHR_Hackathon_2026_team37_3slides.pptx
+++ b/deliverables/JanaMen_DigitalHR_Hackathon_2026_team37_3slides.pptx
@@ -2,15 +2,15 @@
 <file path=ppt/presentation.xml><?xml version="1.0" encoding="utf-8"?>
 <p:presentation xmlns:p="http://schemas.openxmlformats.org/presentationml/2006/main">
   <p:sldMasterIdLst>
-    <p:sldMasterId xmlns:r="http://schemas.openxmlformats.org/officeDocument/2006/relationships" id="2147483648" r:id="R5c32d22ca4814e2d"/>
+    <p:sldMasterId xmlns:r="http://schemas.openxmlformats.org/officeDocument/2006/relationships" id="2147483648" r:id="R9ab49f9ee3d545f7"/>
   </p:sldMasterIdLst>
   <p:notesMasterIdLst>
-    <p:notesMasterId xmlns:r="http://schemas.openxmlformats.org/officeDocument/2006/relationships" r:id="R3479ea5098ff4fb5"/>
+    <p:notesMasterId xmlns:r="http://schemas.openxmlformats.org/officeDocument/2006/relationships" r:id="R0b56a0bedb864e7b"/>
   </p:notesMasterIdLst>
   <p:sldIdLst>
-    <p:sldId xmlns:r="http://schemas.openxmlformats.org/officeDocument/2006/relationships" id="256" r:id="R9b9e9b367ebc4a7c"/>
-    <p:sldId xmlns:r="http://schemas.openxmlformats.org/officeDocument/2006/relationships" id="257" r:id="R7b20a0a58b904aaf"/>
-    <p:sldId xmlns:r="http://schemas.openxmlformats.org/officeDocument/2006/relationships" id="258" r:id="Re83fc5c217154161"/>
+    <p:sldId xmlns:r="http://schemas.openxmlformats.org/officeDocument/2006/relationships" id="256" r:id="R8982235e094e4be3"/>
+    <p:sldId xmlns:r="http://schemas.openxmlformats.org/officeDocument/2006/relationships" id="257" r:id="R3be493eedc364a77"/>
+    <p:sldId xmlns:r="http://schemas.openxmlformats.org/officeDocument/2006/relationships" id="258" r:id="R5ed43c70565446d7"/>
   </p:sldIdLst>
   <p:sldSz cx="9144000" cy="5143500"/>
   <p:notesSz cx="6858000" cy="9144000"/>
@@ -926,7 +926,7 @@
           <p:cNvPr id="10" name="Google Shape;10;p5">
             <a:extLst xmlns:a="http://schemas.openxmlformats.org/drawingml/2006/main">
               <a:ext uri="{FF2B5EF4-FFF2-40B4-BE49-F238E27FC236}">
-                <a16:creationId xmlns:a16="http://schemas.microsoft.com/office/drawing/2014/main" id="{B99974B6-E695-447F-8C1D-52A82D09E043}"/>
+                <a16:creationId xmlns:a16="http://schemas.microsoft.com/office/drawing/2014/main" id="{7D9E3097-F1CE-4320-8B92-2F1617630A05}"/>
               </a:ext>
             </a:extLst>
           </p:cNvPr>
@@ -1090,7 +1090,7 @@
           <p:cNvPr id="11" name="Google Shape;11;p5">
             <a:extLst xmlns:a="http://schemas.openxmlformats.org/drawingml/2006/main">
               <a:ext uri="{FF2B5EF4-FFF2-40B4-BE49-F238E27FC236}">
-                <a16:creationId xmlns:a16="http://schemas.microsoft.com/office/drawing/2014/main" id="{E449928D-919B-4913-9DBF-1C442B2BD797}"/>
+                <a16:creationId xmlns:a16="http://schemas.microsoft.com/office/drawing/2014/main" id="{504048B8-978B-440F-98F6-B75AC3E665A0}"/>
               </a:ext>
             </a:extLst>
           </p:cNvPr>
@@ -1254,7 +1254,7 @@
           <p:cNvPr id="12" name="Google Shape;12;p5">
             <a:extLst xmlns:a="http://schemas.openxmlformats.org/drawingml/2006/main">
               <a:ext uri="{FF2B5EF4-FFF2-40B4-BE49-F238E27FC236}">
-                <a16:creationId xmlns:a16="http://schemas.microsoft.com/office/drawing/2014/main" id="{72E59799-3B60-4882-81A8-4D23A0612B59}"/>
+                <a16:creationId xmlns:a16="http://schemas.microsoft.com/office/drawing/2014/main" id="{962897C0-5B56-4F7A-B9AA-643E638104A9}"/>
               </a:ext>
             </a:extLst>
           </p:cNvPr>
@@ -1548,7 +1548,7 @@
           <p:cNvPr id="45" name="Google Shape;45;p14">
             <a:extLst xmlns:a="http://schemas.openxmlformats.org/drawingml/2006/main">
               <a:ext uri="{FF2B5EF4-FFF2-40B4-BE49-F238E27FC236}">
-                <a16:creationId xmlns:a16="http://schemas.microsoft.com/office/drawing/2014/main" id="{C197854B-9CC7-4CD7-852C-2471C2D4057A}"/>
+                <a16:creationId xmlns:a16="http://schemas.microsoft.com/office/drawing/2014/main" id="{C08BD327-A852-4D2F-924A-FE3A82F9C771}"/>
               </a:ext>
             </a:extLst>
           </p:cNvPr>
@@ -1716,7 +1716,7 @@
           <p:cNvPr id="46" name="Google Shape;46;p14">
             <a:extLst xmlns:a="http://schemas.openxmlformats.org/drawingml/2006/main">
               <a:ext uri="{FF2B5EF4-FFF2-40B4-BE49-F238E27FC236}">
-                <a16:creationId xmlns:a16="http://schemas.microsoft.com/office/drawing/2014/main" id="{3271B577-0348-4D9E-8657-75AB62C729D5}"/>
+                <a16:creationId xmlns:a16="http://schemas.microsoft.com/office/drawing/2014/main" id="{52DAAEB0-76B1-4824-9E9A-CB339445958E}"/>
               </a:ext>
             </a:extLst>
           </p:cNvPr>
@@ -1880,7 +1880,7 @@
           <p:cNvPr id="47" name="Google Shape;47;p14">
             <a:extLst xmlns:a="http://schemas.openxmlformats.org/drawingml/2006/main">
               <a:ext uri="{FF2B5EF4-FFF2-40B4-BE49-F238E27FC236}">
-                <a16:creationId xmlns:a16="http://schemas.microsoft.com/office/drawing/2014/main" id="{EF25DD13-E485-43E4-8B90-E184B353377D}"/>
+                <a16:creationId xmlns:a16="http://schemas.microsoft.com/office/drawing/2014/main" id="{2CF601F9-DB14-47A5-850F-3BE2F3A9C1AD}"/>
               </a:ext>
             </a:extLst>
           </p:cNvPr>
@@ -2174,7 +2174,7 @@
           <p:cNvPr id="49" name="Google Shape;49;p15">
             <a:extLst xmlns:a="http://schemas.openxmlformats.org/drawingml/2006/main">
               <a:ext uri="{FF2B5EF4-FFF2-40B4-BE49-F238E27FC236}">
-                <a16:creationId xmlns:a16="http://schemas.microsoft.com/office/drawing/2014/main" id="{57B24D39-F76D-41BC-9B5B-8D54E2BF3748}"/>
+                <a16:creationId xmlns:a16="http://schemas.microsoft.com/office/drawing/2014/main" id="{D4DDFDC8-ACD4-4644-9819-B469FB7276F7}"/>
               </a:ext>
             </a:extLst>
           </p:cNvPr>
@@ -2468,7 +2468,7 @@
           <p:cNvPr id="14" name="Google Shape;14;p6">
             <a:extLst xmlns:a="http://schemas.openxmlformats.org/drawingml/2006/main">
               <a:ext uri="{FF2B5EF4-FFF2-40B4-BE49-F238E27FC236}">
-                <a16:creationId xmlns:a16="http://schemas.microsoft.com/office/drawing/2014/main" id="{0898942F-1A74-49B9-9BE0-B82D4B60C482}"/>
+                <a16:creationId xmlns:a16="http://schemas.microsoft.com/office/drawing/2014/main" id="{B7EEF452-72EB-461D-8E6B-34728289D00C}"/>
               </a:ext>
             </a:extLst>
           </p:cNvPr>
@@ -2632,7 +2632,7 @@
           <p:cNvPr id="15" name="Google Shape;15;p6">
             <a:extLst xmlns:a="http://schemas.openxmlformats.org/drawingml/2006/main">
               <a:ext uri="{FF2B5EF4-FFF2-40B4-BE49-F238E27FC236}">
-                <a16:creationId xmlns:a16="http://schemas.microsoft.com/office/drawing/2014/main" id="{3444D056-BDB0-42D9-9F35-1CBAC0B40C36}"/>
+                <a16:creationId xmlns:a16="http://schemas.microsoft.com/office/drawing/2014/main" id="{0EC322C3-B515-4CD9-AE19-BDE52EB0648A}"/>
               </a:ext>
             </a:extLst>
           </p:cNvPr>
@@ -2796,7 +2796,7 @@
           <p:cNvPr id="16" name="Google Shape;16;p6">
             <a:extLst xmlns:a="http://schemas.openxmlformats.org/drawingml/2006/main">
               <a:ext uri="{FF2B5EF4-FFF2-40B4-BE49-F238E27FC236}">
-                <a16:creationId xmlns:a16="http://schemas.microsoft.com/office/drawing/2014/main" id="{7CCA6BE3-BAD5-4ADC-AD80-F82C6431973D}"/>
+                <a16:creationId xmlns:a16="http://schemas.microsoft.com/office/drawing/2014/main" id="{7EDFC614-FECE-4527-916B-3F56F79843E9}"/>
               </a:ext>
             </a:extLst>
           </p:cNvPr>
@@ -3090,7 +3090,7 @@
           <p:cNvPr id="18" name="Google Shape;18;p7">
             <a:extLst xmlns:a="http://schemas.openxmlformats.org/drawingml/2006/main">
               <a:ext uri="{FF2B5EF4-FFF2-40B4-BE49-F238E27FC236}">
-                <a16:creationId xmlns:a16="http://schemas.microsoft.com/office/drawing/2014/main" id="{9F3D211A-52DD-40ED-9ACC-8F0E105D9855}"/>
+                <a16:creationId xmlns:a16="http://schemas.microsoft.com/office/drawing/2014/main" id="{F3AADD98-A230-411A-87FD-8A5413EC7BF7}"/>
               </a:ext>
             </a:extLst>
           </p:cNvPr>
@@ -3254,7 +3254,7 @@
           <p:cNvPr id="19" name="Google Shape;19;p7">
             <a:extLst xmlns:a="http://schemas.openxmlformats.org/drawingml/2006/main">
               <a:ext uri="{FF2B5EF4-FFF2-40B4-BE49-F238E27FC236}">
-                <a16:creationId xmlns:a16="http://schemas.microsoft.com/office/drawing/2014/main" id="{48B822D9-CDF8-4A4D-91BC-0D8CF1BA9B73}"/>
+                <a16:creationId xmlns:a16="http://schemas.microsoft.com/office/drawing/2014/main" id="{8CDC5D62-CD68-4F30-8500-02BEAC465A99}"/>
               </a:ext>
             </a:extLst>
           </p:cNvPr>
@@ -3548,7 +3548,7 @@
           <p:cNvPr id="21" name="Google Shape;21;p8">
             <a:extLst xmlns:a="http://schemas.openxmlformats.org/drawingml/2006/main">
               <a:ext uri="{FF2B5EF4-FFF2-40B4-BE49-F238E27FC236}">
-                <a16:creationId xmlns:a16="http://schemas.microsoft.com/office/drawing/2014/main" id="{F64E00F2-0AC2-4457-B3A0-EE6642CEBB5D}"/>
+                <a16:creationId xmlns:a16="http://schemas.microsoft.com/office/drawing/2014/main" id="{A4F4CD16-D137-4069-8008-DC83DD3D7051}"/>
               </a:ext>
             </a:extLst>
           </p:cNvPr>
@@ -3712,7 +3712,7 @@
           <p:cNvPr id="22" name="Google Shape;22;p8">
             <a:extLst xmlns:a="http://schemas.openxmlformats.org/drawingml/2006/main">
               <a:ext uri="{FF2B5EF4-FFF2-40B4-BE49-F238E27FC236}">
-                <a16:creationId xmlns:a16="http://schemas.microsoft.com/office/drawing/2014/main" id="{1144BB71-5580-46F7-83B1-C80C17851E79}"/>
+                <a16:creationId xmlns:a16="http://schemas.microsoft.com/office/drawing/2014/main" id="{2DD1336A-3EA2-44F2-B69E-CD0F8A0286E1}"/>
               </a:ext>
             </a:extLst>
           </p:cNvPr>
@@ -3876,7 +3876,7 @@
           <p:cNvPr id="23" name="Google Shape;23;p8">
             <a:extLst xmlns:a="http://schemas.openxmlformats.org/drawingml/2006/main">
               <a:ext uri="{FF2B5EF4-FFF2-40B4-BE49-F238E27FC236}">
-                <a16:creationId xmlns:a16="http://schemas.microsoft.com/office/drawing/2014/main" id="{253D76BD-EEF3-445D-820B-BBA5A24C235B}"/>
+                <a16:creationId xmlns:a16="http://schemas.microsoft.com/office/drawing/2014/main" id="{0C344E75-D553-467B-A2FF-222932D677FD}"/>
               </a:ext>
             </a:extLst>
           </p:cNvPr>
@@ -4040,7 +4040,7 @@
           <p:cNvPr id="24" name="Google Shape;24;p8">
             <a:extLst xmlns:a="http://schemas.openxmlformats.org/drawingml/2006/main">
               <a:ext uri="{FF2B5EF4-FFF2-40B4-BE49-F238E27FC236}">
-                <a16:creationId xmlns:a16="http://schemas.microsoft.com/office/drawing/2014/main" id="{48F221FA-4915-4936-9837-ED852D7D6071}"/>
+                <a16:creationId xmlns:a16="http://schemas.microsoft.com/office/drawing/2014/main" id="{764AC636-AD52-4EB8-BED6-7BED3803F1D1}"/>
               </a:ext>
             </a:extLst>
           </p:cNvPr>
@@ -4334,7 +4334,7 @@
           <p:cNvPr id="26" name="Google Shape;26;p9">
             <a:extLst xmlns:a="http://schemas.openxmlformats.org/drawingml/2006/main">
               <a:ext uri="{FF2B5EF4-FFF2-40B4-BE49-F238E27FC236}">
-                <a16:creationId xmlns:a16="http://schemas.microsoft.com/office/drawing/2014/main" id="{943863D2-19CB-4F21-9930-6FB173E80302}"/>
+                <a16:creationId xmlns:a16="http://schemas.microsoft.com/office/drawing/2014/main" id="{84354EC5-8B1B-42AF-B8D7-9037D84B6968}"/>
               </a:ext>
             </a:extLst>
           </p:cNvPr>
@@ -4498,7 +4498,7 @@
           <p:cNvPr id="27" name="Google Shape;27;p9">
             <a:extLst xmlns:a="http://schemas.openxmlformats.org/drawingml/2006/main">
               <a:ext uri="{FF2B5EF4-FFF2-40B4-BE49-F238E27FC236}">
-                <a16:creationId xmlns:a16="http://schemas.microsoft.com/office/drawing/2014/main" id="{D68DB300-2121-40D6-85B3-6EBC2ECD9766}"/>
+                <a16:creationId xmlns:a16="http://schemas.microsoft.com/office/drawing/2014/main" id="{8032788F-1427-4446-98A6-9601F13F3B8E}"/>
               </a:ext>
             </a:extLst>
           </p:cNvPr>
@@ -4792,7 +4792,7 @@
           <p:cNvPr id="29" name="Google Shape;29;p10">
             <a:extLst xmlns:a="http://schemas.openxmlformats.org/drawingml/2006/main">
               <a:ext uri="{FF2B5EF4-FFF2-40B4-BE49-F238E27FC236}">
-                <a16:creationId xmlns:a16="http://schemas.microsoft.com/office/drawing/2014/main" id="{3842829C-55D0-4B66-9931-58D8E828A05E}"/>
+                <a16:creationId xmlns:a16="http://schemas.microsoft.com/office/drawing/2014/main" id="{EA9A1B22-C572-4797-96E5-383A3762CF74}"/>
               </a:ext>
             </a:extLst>
           </p:cNvPr>
@@ -4956,7 +4956,7 @@
           <p:cNvPr id="30" name="Google Shape;30;p10">
             <a:extLst xmlns:a="http://schemas.openxmlformats.org/drawingml/2006/main">
               <a:ext uri="{FF2B5EF4-FFF2-40B4-BE49-F238E27FC236}">
-                <a16:creationId xmlns:a16="http://schemas.microsoft.com/office/drawing/2014/main" id="{13D6EBB1-A953-420C-A134-8C5BD36D4618}"/>
+                <a16:creationId xmlns:a16="http://schemas.microsoft.com/office/drawing/2014/main" id="{52661EE5-8731-4D93-9097-1970BEAFAD4D}"/>
               </a:ext>
             </a:extLst>
           </p:cNvPr>
@@ -5120,7 +5120,7 @@
           <p:cNvPr id="31" name="Google Shape;31;p10">
             <a:extLst xmlns:a="http://schemas.openxmlformats.org/drawingml/2006/main">
               <a:ext uri="{FF2B5EF4-FFF2-40B4-BE49-F238E27FC236}">
-                <a16:creationId xmlns:a16="http://schemas.microsoft.com/office/drawing/2014/main" id="{815C2D66-3D98-4E8A-B85A-A9CCE267F362}"/>
+                <a16:creationId xmlns:a16="http://schemas.microsoft.com/office/drawing/2014/main" id="{D1DBA6A7-E821-49FE-BA94-064BB34FF2BD}"/>
               </a:ext>
             </a:extLst>
           </p:cNvPr>
@@ -5414,7 +5414,7 @@
           <p:cNvPr id="33" name="Google Shape;33;p11">
             <a:extLst xmlns:a="http://schemas.openxmlformats.org/drawingml/2006/main">
               <a:ext uri="{FF2B5EF4-FFF2-40B4-BE49-F238E27FC236}">
-                <a16:creationId xmlns:a16="http://schemas.microsoft.com/office/drawing/2014/main" id="{60EA6B31-6CB9-4540-BCAA-CF4A801BCFBF}"/>
+                <a16:creationId xmlns:a16="http://schemas.microsoft.com/office/drawing/2014/main" id="{88BE1956-EFF6-4FE9-9422-8EF504B07C3A}"/>
               </a:ext>
             </a:extLst>
           </p:cNvPr>
@@ -5578,7 +5578,7 @@
           <p:cNvPr id="34" name="Google Shape;34;p11">
             <a:extLst xmlns:a="http://schemas.openxmlformats.org/drawingml/2006/main">
               <a:ext uri="{FF2B5EF4-FFF2-40B4-BE49-F238E27FC236}">
-                <a16:creationId xmlns:a16="http://schemas.microsoft.com/office/drawing/2014/main" id="{4D587F19-84EE-4E84-B980-FF1B2FFE9798}"/>
+                <a16:creationId xmlns:a16="http://schemas.microsoft.com/office/drawing/2014/main" id="{2656A355-7457-4A0A-BA90-50AF3F72CD5C}"/>
               </a:ext>
             </a:extLst>
           </p:cNvPr>
@@ -5872,7 +5872,7 @@
           <p:cNvPr id="36" name="Google Shape;36;p12">
             <a:extLst xmlns:a="http://schemas.openxmlformats.org/drawingml/2006/main">
               <a:ext uri="{FF2B5EF4-FFF2-40B4-BE49-F238E27FC236}">
-                <a16:creationId xmlns:a16="http://schemas.microsoft.com/office/drawing/2014/main" id="{95E507A5-3EE2-494A-A45A-E22BB57E8C7C}"/>
+                <a16:creationId xmlns:a16="http://schemas.microsoft.com/office/drawing/2014/main" id="{4C517D0F-41C8-4231-8883-ABABD7F3E3D0}"/>
               </a:ext>
             </a:extLst>
           </p:cNvPr>
@@ -5938,7 +5938,7 @@
           <p:cNvPr id="37" name="Google Shape;37;p12">
             <a:extLst xmlns:a="http://schemas.openxmlformats.org/drawingml/2006/main">
               <a:ext uri="{FF2B5EF4-FFF2-40B4-BE49-F238E27FC236}">
-                <a16:creationId xmlns:a16="http://schemas.microsoft.com/office/drawing/2014/main" id="{9E44671B-0C77-4D17-953B-1C38B7848D8E}"/>
+                <a16:creationId xmlns:a16="http://schemas.microsoft.com/office/drawing/2014/main" id="{9FD29225-46DB-4DFF-B2CD-4C0784998E72}"/>
               </a:ext>
             </a:extLst>
           </p:cNvPr>
@@ -6102,7 +6102,7 @@
           <p:cNvPr id="38" name="Google Shape;38;p12">
             <a:extLst xmlns:a="http://schemas.openxmlformats.org/drawingml/2006/main">
               <a:ext uri="{FF2B5EF4-FFF2-40B4-BE49-F238E27FC236}">
-                <a16:creationId xmlns:a16="http://schemas.microsoft.com/office/drawing/2014/main" id="{3F2228B7-8B41-485A-8127-4A6AAADC7C9B}"/>
+                <a16:creationId xmlns:a16="http://schemas.microsoft.com/office/drawing/2014/main" id="{82AC2979-827D-41D7-8A4D-CF09656896D2}"/>
               </a:ext>
             </a:extLst>
           </p:cNvPr>
@@ -6266,7 +6266,7 @@
           <p:cNvPr id="39" name="Google Shape;39;p12">
             <a:extLst xmlns:a="http://schemas.openxmlformats.org/drawingml/2006/main">
               <a:ext uri="{FF2B5EF4-FFF2-40B4-BE49-F238E27FC236}">
-                <a16:creationId xmlns:a16="http://schemas.microsoft.com/office/drawing/2014/main" id="{AB0DFF35-5550-4447-A187-223639ED757C}"/>
+                <a16:creationId xmlns:a16="http://schemas.microsoft.com/office/drawing/2014/main" id="{268CF97B-CD59-4BE8-8499-D242A0440220}"/>
               </a:ext>
             </a:extLst>
           </p:cNvPr>
@@ -6430,7 +6430,7 @@
           <p:cNvPr id="40" name="Google Shape;40;p12">
             <a:extLst xmlns:a="http://schemas.openxmlformats.org/drawingml/2006/main">
               <a:ext uri="{FF2B5EF4-FFF2-40B4-BE49-F238E27FC236}">
-                <a16:creationId xmlns:a16="http://schemas.microsoft.com/office/drawing/2014/main" id="{F838A6CF-9AFF-44D6-8EC1-859C08302D04}"/>
+                <a16:creationId xmlns:a16="http://schemas.microsoft.com/office/drawing/2014/main" id="{B72EE85B-72CD-471D-A278-4BBF51131EE1}"/>
               </a:ext>
             </a:extLst>
           </p:cNvPr>
@@ -6724,7 +6724,7 @@
           <p:cNvPr id="42" name="Google Shape;42;p13">
             <a:extLst xmlns:a="http://schemas.openxmlformats.org/drawingml/2006/main">
               <a:ext uri="{FF2B5EF4-FFF2-40B4-BE49-F238E27FC236}">
-                <a16:creationId xmlns:a16="http://schemas.microsoft.com/office/drawing/2014/main" id="{860C786C-77AD-4B4F-A1E5-4F85DB2C0ED7}"/>
+                <a16:creationId xmlns:a16="http://schemas.microsoft.com/office/drawing/2014/main" id="{A67365DF-ADA9-4ECE-8626-5C9115EBFDC7}"/>
               </a:ext>
             </a:extLst>
           </p:cNvPr>
@@ -6776,7 +6776,7 @@
           <p:cNvPr id="43" name="Google Shape;43;p13">
             <a:extLst xmlns:a="http://schemas.openxmlformats.org/drawingml/2006/main">
               <a:ext uri="{FF2B5EF4-FFF2-40B4-BE49-F238E27FC236}">
-                <a16:creationId xmlns:a16="http://schemas.microsoft.com/office/drawing/2014/main" id="{17CFA8DA-C1A6-49AE-A717-2BEE0375A839}"/>
+                <a16:creationId xmlns:a16="http://schemas.microsoft.com/office/drawing/2014/main" id="{B0161CCB-94B2-4DD8-AF5E-62A759BCC7BA}"/>
               </a:ext>
             </a:extLst>
           </p:cNvPr>
@@ -7077,7 +7077,7 @@
           <p:cNvPr id="6" name="Google Shape;6;p4">
             <a:extLst xmlns:a="http://schemas.openxmlformats.org/drawingml/2006/main">
               <a:ext uri="{FF2B5EF4-FFF2-40B4-BE49-F238E27FC236}">
-                <a16:creationId xmlns:a16="http://schemas.microsoft.com/office/drawing/2014/main" id="{A6DA4375-7445-4ED2-A3A6-F1C66E63BE63}"/>
+                <a16:creationId xmlns:a16="http://schemas.microsoft.com/office/drawing/2014/main" id="{E4D9C3ED-0A2A-4986-9D2E-7FF1A5BCB5D0}"/>
               </a:ext>
             </a:extLst>
           </p:cNvPr>
@@ -7340,7 +7340,7 @@
           <p:cNvPr id="7" name="Google Shape;7;p4">
             <a:extLst xmlns:a="http://schemas.openxmlformats.org/drawingml/2006/main">
               <a:ext uri="{FF2B5EF4-FFF2-40B4-BE49-F238E27FC236}">
-                <a16:creationId xmlns:a16="http://schemas.microsoft.com/office/drawing/2014/main" id="{2218E8DA-869C-4FCB-A6B9-CE6BB17F399F}"/>
+                <a16:creationId xmlns:a16="http://schemas.microsoft.com/office/drawing/2014/main" id="{8F687028-CEFB-466A-8161-9C05442066D4}"/>
               </a:ext>
             </a:extLst>
           </p:cNvPr>
@@ -7603,7 +7603,7 @@
           <p:cNvPr id="8" name="Google Shape;8;p4">
             <a:extLst xmlns:a="http://schemas.openxmlformats.org/drawingml/2006/main">
               <a:ext uri="{FF2B5EF4-FFF2-40B4-BE49-F238E27FC236}">
-                <a16:creationId xmlns:a16="http://schemas.microsoft.com/office/drawing/2014/main" id="{BADC514C-9B80-4316-AE10-6EC7CCB9C8D8}"/>
+                <a16:creationId xmlns:a16="http://schemas.microsoft.com/office/drawing/2014/main" id="{A9FBDBB1-C3DA-4444-9EB6-6FD19C466C36}"/>
               </a:ext>
             </a:extLst>
           </p:cNvPr>
@@ -7879,17 +7879,17 @@
   </p:cSld>
   <p:clrMap bg1="lt1" tx1="dk1" bg2="dk2" tx2="lt2" accent1="accent1" accent2="accent2" accent3="accent3" accent4="accent4" accent5="accent5" accent6="accent6" hlink="hlink" folHlink="folHlink"/>
   <p:sldLayoutIdLst>
-    <p:sldLayoutId xmlns:r="http://schemas.openxmlformats.org/officeDocument/2006/relationships" id="2147483649" r:id="Rb472c96d52274a4d"/>
-    <p:sldLayoutId xmlns:r="http://schemas.openxmlformats.org/officeDocument/2006/relationships" id="2147483650" r:id="Ra63e8018d9a0456a"/>
-    <p:sldLayoutId xmlns:r="http://schemas.openxmlformats.org/officeDocument/2006/relationships" id="2147483651" r:id="Re09dd98d42bb4dc7"/>
-    <p:sldLayoutId xmlns:r="http://schemas.openxmlformats.org/officeDocument/2006/relationships" id="2147483652" r:id="R5ea3ff465c624fee"/>
-    <p:sldLayoutId xmlns:r="http://schemas.openxmlformats.org/officeDocument/2006/relationships" id="2147483653" r:id="R98d47c97f3b647c5"/>
-    <p:sldLayoutId xmlns:r="http://schemas.openxmlformats.org/officeDocument/2006/relationships" id="2147483654" r:id="Redab694ee89c481a"/>
-    <p:sldLayoutId xmlns:r="http://schemas.openxmlformats.org/officeDocument/2006/relationships" id="2147483655" r:id="Ree7e9be1802b4ef3"/>
-    <p:sldLayoutId xmlns:r="http://schemas.openxmlformats.org/officeDocument/2006/relationships" id="2147483656" r:id="R7c8e32f4217c4024"/>
-    <p:sldLayoutId xmlns:r="http://schemas.openxmlformats.org/officeDocument/2006/relationships" id="2147483657" r:id="R0ab2b79b16bd4722"/>
-    <p:sldLayoutId xmlns:r="http://schemas.openxmlformats.org/officeDocument/2006/relationships" id="2147483658" r:id="R8bdac9857f424c60"/>
-    <p:sldLayoutId xmlns:r="http://schemas.openxmlformats.org/officeDocument/2006/relationships" id="2147483659" r:id="Rd2c1763e00814ab7"/>
+    <p:sldLayoutId xmlns:r="http://schemas.openxmlformats.org/officeDocument/2006/relationships" id="2147483649" r:id="R5aa8032de97a49c8"/>
+    <p:sldLayoutId xmlns:r="http://schemas.openxmlformats.org/officeDocument/2006/relationships" id="2147483650" r:id="Rc401e25e46dc4af7"/>
+    <p:sldLayoutId xmlns:r="http://schemas.openxmlformats.org/officeDocument/2006/relationships" id="2147483651" r:id="R76ea84a0ab874f48"/>
+    <p:sldLayoutId xmlns:r="http://schemas.openxmlformats.org/officeDocument/2006/relationships" id="2147483652" r:id="Re51e19edea7f4cb7"/>
+    <p:sldLayoutId xmlns:r="http://schemas.openxmlformats.org/officeDocument/2006/relationships" id="2147483653" r:id="R1442ef2aa53248d5"/>
+    <p:sldLayoutId xmlns:r="http://schemas.openxmlformats.org/officeDocument/2006/relationships" id="2147483654" r:id="R52bb9c63f40d4c4f"/>
+    <p:sldLayoutId xmlns:r="http://schemas.openxmlformats.org/officeDocument/2006/relationships" id="2147483655" r:id="Rb3f4bcaf6c0c4fd2"/>
+    <p:sldLayoutId xmlns:r="http://schemas.openxmlformats.org/officeDocument/2006/relationships" id="2147483656" r:id="Rf0d88fc4ae6a4bb0"/>
+    <p:sldLayoutId xmlns:r="http://schemas.openxmlformats.org/officeDocument/2006/relationships" id="2147483657" r:id="R9abbdb2897bf4485"/>
+    <p:sldLayoutId xmlns:r="http://schemas.openxmlformats.org/officeDocument/2006/relationships" id="2147483658" r:id="R45b1d14b0dc84469"/>
+    <p:sldLayoutId xmlns:r="http://schemas.openxmlformats.org/officeDocument/2006/relationships" id="2147483659" r:id="R327d1cdf1f554c96"/>
   </p:sldLayoutIdLst>
   <p:hf sldNum="0" hdr="0" ftr="0" dt="0"/>
   <p:txStyles>
@@ -8836,7 +8836,7 @@
           <p:cNvPr id="54" name="Google Shape;54;p1">
             <a:extLst xmlns:a="http://schemas.openxmlformats.org/drawingml/2006/main">
               <a:ext uri="{FF2B5EF4-FFF2-40B4-BE49-F238E27FC236}">
-                <a16:creationId xmlns:a16="http://schemas.microsoft.com/office/drawing/2014/main" id="{7DAFB301-2E65-46FF-8D32-39957C9049EF}"/>
+                <a16:creationId xmlns:a16="http://schemas.microsoft.com/office/drawing/2014/main" id="{B61DC35D-0A3D-4FCC-BD45-3F48CCBDC60C}"/>
               </a:ext>
             </a:extLst>
           </p:cNvPr>
@@ -8891,7 +8891,7 @@
           <p:cNvPr id="55" name="Google Shape;55;p1">
             <a:extLst xmlns:a="http://schemas.openxmlformats.org/drawingml/2006/main">
               <a:ext uri="{FF2B5EF4-FFF2-40B4-BE49-F238E27FC236}">
-                <a16:creationId xmlns:a16="http://schemas.microsoft.com/office/drawing/2014/main" id="{B76AC645-DA90-4CE6-A558-5BF300FB8D16}"/>
+                <a16:creationId xmlns:a16="http://schemas.microsoft.com/office/drawing/2014/main" id="{E68B809B-5D20-40C9-A0D4-90A0DF84A5F6}"/>
               </a:ext>
             </a:extLst>
           </p:cNvPr>
@@ -8946,7 +8946,7 @@
           <p:cNvPr id="56" name="Google Shape;56;p1">
             <a:extLst xmlns:a="http://schemas.openxmlformats.org/drawingml/2006/main">
               <a:ext uri="{FF2B5EF4-FFF2-40B4-BE49-F238E27FC236}">
-                <a16:creationId xmlns:a16="http://schemas.microsoft.com/office/drawing/2014/main" id="{72EF2277-9F75-4EC4-BAB0-50343193C644}"/>
+                <a16:creationId xmlns:a16="http://schemas.microsoft.com/office/drawing/2014/main" id="{C0D6C0A7-6D12-4838-AFC9-D4083FC0912B}"/>
               </a:ext>
             </a:extLst>
           </p:cNvPr>
@@ -8956,7 +8956,7 @@
           <p:nvPr/>
         </p:nvPicPr>
         <p:blipFill rotWithShape="1">
-          <a:blip xmlns:r="http://schemas.openxmlformats.org/officeDocument/2006/relationships" xmlns:a="http://schemas.openxmlformats.org/drawingml/2006/main" r:embed="Rf2a9ee7986e0429e">
+          <a:blip xmlns:r="http://schemas.openxmlformats.org/officeDocument/2006/relationships" xmlns:a="http://schemas.openxmlformats.org/drawingml/2006/main" r:embed="R6e3921d3a5974493">
             <a:alphaModFix/>
           </a:blip>
           <a:srcRect xmlns:a="http://schemas.openxmlformats.org/drawingml/2006/main" l="0" t="0" r="0" b="0"/>
@@ -8980,7 +8980,7 @@
           <p:cNvPr id="57" name="Google Shape;57;p1">
             <a:extLst xmlns:a="http://schemas.openxmlformats.org/drawingml/2006/main">
               <a:ext uri="{FF2B5EF4-FFF2-40B4-BE49-F238E27FC236}">
-                <a16:creationId xmlns:a16="http://schemas.microsoft.com/office/drawing/2014/main" id="{348BD0D1-F3CC-487B-9911-D81F18BCD942}"/>
+                <a16:creationId xmlns:a16="http://schemas.microsoft.com/office/drawing/2014/main" id="{54CB71C1-0DE8-4496-9873-D0776963C5FD}"/>
               </a:ext>
             </a:extLst>
           </p:cNvPr>
@@ -9050,7 +9050,7 @@
     </p:spTree>
     <p:extLst>
       <p:ext uri="{BB962C8B-B14F-4D97-AF65-F5344CB8AC3E}">
-        <p14:creationId xmlns:p14="http://schemas.microsoft.com/office/powerpoint/2010/main" val="1643395699"/>
+        <p14:creationId xmlns:p14="http://schemas.microsoft.com/office/powerpoint/2010/main" val="2051488737"/>
       </p:ext>
     </p:extLst>
   </p:cSld>
@@ -9074,7 +9074,7 @@
           <p:cNvPr id="62" name="Google Shape;62;p2">
             <a:extLst xmlns:a="http://schemas.openxmlformats.org/drawingml/2006/main">
               <a:ext uri="{FF2B5EF4-FFF2-40B4-BE49-F238E27FC236}">
-                <a16:creationId xmlns:a16="http://schemas.microsoft.com/office/drawing/2014/main" id="{6AEB8462-0CDB-43A2-A3E9-76A5B10C14C3}"/>
+                <a16:creationId xmlns:a16="http://schemas.microsoft.com/office/drawing/2014/main" id="{C9679614-3EF2-4DF4-91F3-017CD969A9FB}"/>
               </a:ext>
             </a:extLst>
           </p:cNvPr>
@@ -9129,7 +9129,7 @@
           <p:cNvPr id="63" name="overview lead">
             <a:extLst xmlns:a="http://schemas.openxmlformats.org/drawingml/2006/main">
               <a:ext uri="{FF2B5EF4-FFF2-40B4-BE49-F238E27FC236}">
-                <a16:creationId xmlns:a16="http://schemas.microsoft.com/office/drawing/2014/main" id="{5DDC18AC-6CED-47EB-B863-2796487443FF}"/>
+                <a16:creationId xmlns:a16="http://schemas.microsoft.com/office/drawing/2014/main" id="{49BF73FF-FC88-484B-90A5-15592EC06B40}"/>
               </a:ext>
             </a:extLst>
           </p:cNvPr>
@@ -9288,7 +9288,7 @@
           <p:cNvPr id="64" name="overview heading 1">
             <a:extLst xmlns:a="http://schemas.openxmlformats.org/drawingml/2006/main">
               <a:ext uri="{FF2B5EF4-FFF2-40B4-BE49-F238E27FC236}">
-                <a16:creationId xmlns:a16="http://schemas.microsoft.com/office/drawing/2014/main" id="{3807CD3A-C1ED-48D6-941A-A01C50D79DA6}"/>
+                <a16:creationId xmlns:a16="http://schemas.microsoft.com/office/drawing/2014/main" id="{3749DBEC-D052-46F1-BBFF-B3D990301703}"/>
               </a:ext>
             </a:extLst>
           </p:cNvPr>
@@ -9447,7 +9447,7 @@
           <p:cNvPr id="65" name="overview detail 1">
             <a:extLst xmlns:a="http://schemas.openxmlformats.org/drawingml/2006/main">
               <a:ext uri="{FF2B5EF4-FFF2-40B4-BE49-F238E27FC236}">
-                <a16:creationId xmlns:a16="http://schemas.microsoft.com/office/drawing/2014/main" id="{D86B9B0F-05C4-4A48-BD26-897A26AE11BB}"/>
+                <a16:creationId xmlns:a16="http://schemas.microsoft.com/office/drawing/2014/main" id="{3B88B743-9C5E-47C2-9869-173A77013CF6}"/>
               </a:ext>
             </a:extLst>
           </p:cNvPr>
@@ -9606,7 +9606,7 @@
           <p:cNvPr id="66" name="overview heading 2">
             <a:extLst xmlns:a="http://schemas.openxmlformats.org/drawingml/2006/main">
               <a:ext uri="{FF2B5EF4-FFF2-40B4-BE49-F238E27FC236}">
-                <a16:creationId xmlns:a16="http://schemas.microsoft.com/office/drawing/2014/main" id="{E53202A5-D1CB-4C07-9BB7-4B9AEF462C6D}"/>
+                <a16:creationId xmlns:a16="http://schemas.microsoft.com/office/drawing/2014/main" id="{1097F577-859F-44CF-853F-90F4646EB5D9}"/>
               </a:ext>
             </a:extLst>
           </p:cNvPr>
@@ -9765,7 +9765,7 @@
           <p:cNvPr id="67" name="overview detail 2">
             <a:extLst xmlns:a="http://schemas.openxmlformats.org/drawingml/2006/main">
               <a:ext uri="{FF2B5EF4-FFF2-40B4-BE49-F238E27FC236}">
-                <a16:creationId xmlns:a16="http://schemas.microsoft.com/office/drawing/2014/main" id="{1C89A93F-0200-46DE-8B9C-BA39FFF85383}"/>
+                <a16:creationId xmlns:a16="http://schemas.microsoft.com/office/drawing/2014/main" id="{51E58EBE-5C38-4F26-8E8D-9C1C7E5E838E}"/>
               </a:ext>
             </a:extLst>
           </p:cNvPr>
@@ -9924,7 +9924,7 @@
           <p:cNvPr id="68" name="overview heading 3">
             <a:extLst xmlns:a="http://schemas.openxmlformats.org/drawingml/2006/main">
               <a:ext uri="{FF2B5EF4-FFF2-40B4-BE49-F238E27FC236}">
-                <a16:creationId xmlns:a16="http://schemas.microsoft.com/office/drawing/2014/main" id="{634EF6A4-5DFB-4567-83DD-1783748794D3}"/>
+                <a16:creationId xmlns:a16="http://schemas.microsoft.com/office/drawing/2014/main" id="{5E699ACF-7866-43DE-B5E8-7E645CE759D5}"/>
               </a:ext>
             </a:extLst>
           </p:cNvPr>
@@ -10083,7 +10083,7 @@
           <p:cNvPr id="69" name="overview detail 3">
             <a:extLst xmlns:a="http://schemas.openxmlformats.org/drawingml/2006/main">
               <a:ext uri="{FF2B5EF4-FFF2-40B4-BE49-F238E27FC236}">
-                <a16:creationId xmlns:a16="http://schemas.microsoft.com/office/drawing/2014/main" id="{A3CC20A2-1A1D-4B11-8C1E-5520D9AE1671}"/>
+                <a16:creationId xmlns:a16="http://schemas.microsoft.com/office/drawing/2014/main" id="{66292ADE-D735-4C0A-A18A-703706BCDF54}"/>
               </a:ext>
             </a:extLst>
           </p:cNvPr>
@@ -10242,7 +10242,7 @@
           <p:cNvPr id="70" name="overview heading 4">
             <a:extLst xmlns:a="http://schemas.openxmlformats.org/drawingml/2006/main">
               <a:ext uri="{FF2B5EF4-FFF2-40B4-BE49-F238E27FC236}">
-                <a16:creationId xmlns:a16="http://schemas.microsoft.com/office/drawing/2014/main" id="{BD1CC4F2-2CC6-47F2-A810-3466B33E2A56}"/>
+                <a16:creationId xmlns:a16="http://schemas.microsoft.com/office/drawing/2014/main" id="{2E77A26C-DD3F-400C-B2FB-29867D0FD4ED}"/>
               </a:ext>
             </a:extLst>
           </p:cNvPr>
@@ -10401,7 +10401,7 @@
           <p:cNvPr id="71" name="overview detail 4">
             <a:extLst xmlns:a="http://schemas.openxmlformats.org/drawingml/2006/main">
               <a:ext uri="{FF2B5EF4-FFF2-40B4-BE49-F238E27FC236}">
-                <a16:creationId xmlns:a16="http://schemas.microsoft.com/office/drawing/2014/main" id="{1507A9CB-E839-4768-BB32-CDDA63248C77}"/>
+                <a16:creationId xmlns:a16="http://schemas.microsoft.com/office/drawing/2014/main" id="{83BC7CBC-D803-479D-A194-B0A9BB30102C}"/>
               </a:ext>
             </a:extLst>
           </p:cNvPr>
@@ -10558,7 +10558,7 @@
     </p:spTree>
     <p:extLst>
       <p:ext uri="{BB962C8B-B14F-4D97-AF65-F5344CB8AC3E}">
-        <p14:creationId xmlns:p14="http://schemas.microsoft.com/office/powerpoint/2010/main" val="1131686227"/>
+        <p14:creationId xmlns:p14="http://schemas.microsoft.com/office/powerpoint/2010/main" val="293014445"/>
       </p:ext>
     </p:extLst>
   </p:cSld>
@@ -10582,7 +10582,7 @@
           <p:cNvPr id="68" name="Google Shape;68;p3">
             <a:extLst xmlns:a="http://schemas.openxmlformats.org/drawingml/2006/main">
               <a:ext uri="{FF2B5EF4-FFF2-40B4-BE49-F238E27FC236}">
-                <a16:creationId xmlns:a16="http://schemas.microsoft.com/office/drawing/2014/main" id="{0E145F6E-33DF-4AE3-BF73-662C7026BF47}"/>
+                <a16:creationId xmlns:a16="http://schemas.microsoft.com/office/drawing/2014/main" id="{C30CC277-D252-4B91-A848-ABB2895676B8}"/>
               </a:ext>
             </a:extLst>
           </p:cNvPr>
@@ -10626,1350 +10626,16 @@
               <a:buNone/>
             </a:pPr>
             <a:r>
-              <a:t>Демонстрация прототипа</a:t>
+              <a:t>Демонстрация</a:t>
             </a:r>
             <a:endParaRPr/>
-          </a:p>
-        </p:txBody>
-      </p:sp>
-      <p:sp>
-        <p:nvSpPr>
-          <p:cNvPr id="69" name="demo label">
-            <a:extLst xmlns:a="http://schemas.openxmlformats.org/drawingml/2006/main">
-              <a:ext uri="{FF2B5EF4-FFF2-40B4-BE49-F238E27FC236}">
-                <a16:creationId xmlns:a16="http://schemas.microsoft.com/office/drawing/2014/main" id="{4D39AC91-771B-437E-B71E-09959E373902}"/>
-              </a:ext>
-            </a:extLst>
-          </p:cNvPr>
-          <p:cNvSpPr>
-            <a:spLocks xmlns:a="http://schemas.openxmlformats.org/drawingml/2006/main" noGrp="1"/>
-          </p:cNvSpPr>
-          <p:nvPr/>
-        </p:nvSpPr>
-        <p:spPr>
-          <a:xfrm xmlns:a="http://schemas.openxmlformats.org/drawingml/2006/main">
-            <a:off x="400050" y="1181100"/>
-            <a:ext cx="8343900" cy="209550"/>
-          </a:xfrm>
-          <a:prstGeom xmlns:a="http://schemas.openxmlformats.org/drawingml/2006/main" prst="rect">
-            <a:avLst/>
-          </a:prstGeom>
-          <a:noFill xmlns:a="http://schemas.openxmlformats.org/drawingml/2006/main"/>
-          <a:ln xmlns:a="http://schemas.openxmlformats.org/drawingml/2006/main" w="0">
-            <a:noFill/>
-            <a:prstDash val="solid"/>
-          </a:ln>
-        </p:spPr>
-        <p:txBody>
-          <a:bodyPr xmlns:a="http://schemas.openxmlformats.org/drawingml/2006/main" wrap="square" lIns="0" tIns="0" rIns="0" bIns="0" anchor="t">
-            <a:noAutofit/>
-          </a:bodyPr>
-          <a:lstStyle xmlns:a="http://schemas.openxmlformats.org/drawingml/2006/main">
-            <a:defPPr algn="l">
-              <a:defRPr sz="1125" b="1">
-                <a:solidFill>
-                  <a:srgbClr val="595959"/>
-                </a:solidFill>
-                <a:latin typeface="Arial"/>
-                <a:ea typeface="Arial"/>
-                <a:cs typeface="Arial"/>
-              </a:defRPr>
-            </a:defPPr>
-            <a:lvl1pPr algn="l">
-              <a:defRPr sz="1125" b="1">
-                <a:solidFill>
-                  <a:srgbClr val="595959"/>
-                </a:solidFill>
-                <a:latin typeface="Arial"/>
-                <a:ea typeface="Arial"/>
-                <a:cs typeface="Arial"/>
-              </a:defRPr>
-            </a:lvl1pPr>
-            <a:lvl2pPr algn="l">
-              <a:defRPr sz="1125" b="1">
-                <a:solidFill>
-                  <a:srgbClr val="595959"/>
-                </a:solidFill>
-                <a:latin typeface="Arial"/>
-                <a:ea typeface="Arial"/>
-                <a:cs typeface="Arial"/>
-              </a:defRPr>
-            </a:lvl2pPr>
-            <a:lvl3pPr algn="l">
-              <a:defRPr sz="1125" b="1">
-                <a:solidFill>
-                  <a:srgbClr val="595959"/>
-                </a:solidFill>
-                <a:latin typeface="Arial"/>
-                <a:ea typeface="Arial"/>
-                <a:cs typeface="Arial"/>
-              </a:defRPr>
-            </a:lvl3pPr>
-            <a:lvl4pPr algn="l">
-              <a:defRPr sz="1125" b="1">
-                <a:solidFill>
-                  <a:srgbClr val="595959"/>
-                </a:solidFill>
-                <a:latin typeface="Arial"/>
-                <a:ea typeface="Arial"/>
-                <a:cs typeface="Arial"/>
-              </a:defRPr>
-            </a:lvl4pPr>
-            <a:lvl5pPr algn="l">
-              <a:defRPr sz="1125" b="1">
-                <a:solidFill>
-                  <a:srgbClr val="595959"/>
-                </a:solidFill>
-                <a:latin typeface="Arial"/>
-                <a:ea typeface="Arial"/>
-                <a:cs typeface="Arial"/>
-              </a:defRPr>
-            </a:lvl5pPr>
-            <a:lvl6pPr algn="l">
-              <a:defRPr sz="1125" b="1">
-                <a:solidFill>
-                  <a:srgbClr val="595959"/>
-                </a:solidFill>
-                <a:latin typeface="Arial"/>
-                <a:ea typeface="Arial"/>
-                <a:cs typeface="Arial"/>
-              </a:defRPr>
-            </a:lvl6pPr>
-            <a:lvl7pPr algn="l">
-              <a:defRPr sz="1125" b="1">
-                <a:solidFill>
-                  <a:srgbClr val="595959"/>
-                </a:solidFill>
-                <a:latin typeface="Arial"/>
-                <a:ea typeface="Arial"/>
-                <a:cs typeface="Arial"/>
-              </a:defRPr>
-            </a:lvl7pPr>
-            <a:lvl8pPr algn="l">
-              <a:defRPr sz="1125" b="1">
-                <a:solidFill>
-                  <a:srgbClr val="595959"/>
-                </a:solidFill>
-                <a:latin typeface="Arial"/>
-                <a:ea typeface="Arial"/>
-                <a:cs typeface="Arial"/>
-              </a:defRPr>
-            </a:lvl8pPr>
-            <a:lvl9pPr algn="l">
-              <a:defRPr sz="1125" b="1">
-                <a:solidFill>
-                  <a:srgbClr val="595959"/>
-                </a:solidFill>
-                <a:latin typeface="Arial"/>
-                <a:ea typeface="Arial"/>
-                <a:cs typeface="Arial"/>
-              </a:defRPr>
-            </a:lvl9pPr>
-          </a:lstStyle>
-          <a:p xmlns:a="http://schemas.openxmlformats.org/drawingml/2006/main">
-            <a:pPr algn="l">
-              <a:defRPr sz="1125" b="1">
-                <a:solidFill>
-                  <a:srgbClr val="595959"/>
-                </a:solidFill>
-                <a:latin typeface="Arial"/>
-                <a:ea typeface="Arial"/>
-                <a:cs typeface="Arial"/>
-              </a:defRPr>
-            </a:pPr>
-            <a:r>
-              <a:rPr sz="1125" b="1">
-                <a:solidFill>
-                  <a:srgbClr val="595959"/>
-                </a:solidFill>
-                <a:latin typeface="Arial"/>
-                <a:ea typeface="Arial"/>
-                <a:cs typeface="Arial"/>
-              </a:rPr>
-              <a:t>ОБНОВЛЕНИЕ ПРАВИЛА</a:t>
-            </a:r>
-          </a:p>
-        </p:txBody>
-      </p:sp>
-      <p:sp>
-        <p:nvSpPr>
-          <p:cNvPr id="70" name="before label">
-            <a:extLst xmlns:a="http://schemas.openxmlformats.org/drawingml/2006/main">
-              <a:ext uri="{FF2B5EF4-FFF2-40B4-BE49-F238E27FC236}">
-                <a16:creationId xmlns:a16="http://schemas.microsoft.com/office/drawing/2014/main" id="{36C6281C-8E73-4745-A680-8EFC5E227626}"/>
-              </a:ext>
-            </a:extLst>
-          </p:cNvPr>
-          <p:cNvSpPr>
-            <a:spLocks xmlns:a="http://schemas.openxmlformats.org/drawingml/2006/main" noGrp="1"/>
-          </p:cNvSpPr>
-          <p:nvPr/>
-        </p:nvSpPr>
-        <p:spPr>
-          <a:xfrm xmlns:a="http://schemas.openxmlformats.org/drawingml/2006/main">
-            <a:off x="400050" y="1571625"/>
-            <a:ext cx="3857625" cy="228600"/>
-          </a:xfrm>
-          <a:prstGeom xmlns:a="http://schemas.openxmlformats.org/drawingml/2006/main" prst="rect">
-            <a:avLst/>
-          </a:prstGeom>
-          <a:noFill xmlns:a="http://schemas.openxmlformats.org/drawingml/2006/main"/>
-          <a:ln xmlns:a="http://schemas.openxmlformats.org/drawingml/2006/main" w="0">
-            <a:noFill/>
-            <a:prstDash val="solid"/>
-          </a:ln>
-        </p:spPr>
-        <p:txBody>
-          <a:bodyPr xmlns:a="http://schemas.openxmlformats.org/drawingml/2006/main" wrap="square" lIns="0" tIns="0" rIns="0" bIns="0" anchor="t">
-            <a:noAutofit/>
-          </a:bodyPr>
-          <a:lstStyle xmlns:a="http://schemas.openxmlformats.org/drawingml/2006/main">
-            <a:defPPr algn="l">
-              <a:defRPr sz="1200" b="1">
-                <a:solidFill>
-                  <a:srgbClr val="595959"/>
-                </a:solidFill>
-                <a:latin typeface="Arial"/>
-                <a:ea typeface="Arial"/>
-                <a:cs typeface="Arial"/>
-              </a:defRPr>
-            </a:defPPr>
-            <a:lvl1pPr algn="l">
-              <a:defRPr sz="1200" b="1">
-                <a:solidFill>
-                  <a:srgbClr val="595959"/>
-                </a:solidFill>
-                <a:latin typeface="Arial"/>
-                <a:ea typeface="Arial"/>
-                <a:cs typeface="Arial"/>
-              </a:defRPr>
-            </a:lvl1pPr>
-            <a:lvl2pPr algn="l">
-              <a:defRPr sz="1200" b="1">
-                <a:solidFill>
-                  <a:srgbClr val="595959"/>
-                </a:solidFill>
-                <a:latin typeface="Arial"/>
-                <a:ea typeface="Arial"/>
-                <a:cs typeface="Arial"/>
-              </a:defRPr>
-            </a:lvl2pPr>
-            <a:lvl3pPr algn="l">
-              <a:defRPr sz="1200" b="1">
-                <a:solidFill>
-                  <a:srgbClr val="595959"/>
-                </a:solidFill>
-                <a:latin typeface="Arial"/>
-                <a:ea typeface="Arial"/>
-                <a:cs typeface="Arial"/>
-              </a:defRPr>
-            </a:lvl3pPr>
-            <a:lvl4pPr algn="l">
-              <a:defRPr sz="1200" b="1">
-                <a:solidFill>
-                  <a:srgbClr val="595959"/>
-                </a:solidFill>
-                <a:latin typeface="Arial"/>
-                <a:ea typeface="Arial"/>
-                <a:cs typeface="Arial"/>
-              </a:defRPr>
-            </a:lvl4pPr>
-            <a:lvl5pPr algn="l">
-              <a:defRPr sz="1200" b="1">
-                <a:solidFill>
-                  <a:srgbClr val="595959"/>
-                </a:solidFill>
-                <a:latin typeface="Arial"/>
-                <a:ea typeface="Arial"/>
-                <a:cs typeface="Arial"/>
-              </a:defRPr>
-            </a:lvl5pPr>
-            <a:lvl6pPr algn="l">
-              <a:defRPr sz="1200" b="1">
-                <a:solidFill>
-                  <a:srgbClr val="595959"/>
-                </a:solidFill>
-                <a:latin typeface="Arial"/>
-                <a:ea typeface="Arial"/>
-                <a:cs typeface="Arial"/>
-              </a:defRPr>
-            </a:lvl6pPr>
-            <a:lvl7pPr algn="l">
-              <a:defRPr sz="1200" b="1">
-                <a:solidFill>
-                  <a:srgbClr val="595959"/>
-                </a:solidFill>
-                <a:latin typeface="Arial"/>
-                <a:ea typeface="Arial"/>
-                <a:cs typeface="Arial"/>
-              </a:defRPr>
-            </a:lvl7pPr>
-            <a:lvl8pPr algn="l">
-              <a:defRPr sz="1200" b="1">
-                <a:solidFill>
-                  <a:srgbClr val="595959"/>
-                </a:solidFill>
-                <a:latin typeface="Arial"/>
-                <a:ea typeface="Arial"/>
-                <a:cs typeface="Arial"/>
-              </a:defRPr>
-            </a:lvl8pPr>
-            <a:lvl9pPr algn="l">
-              <a:defRPr sz="1200" b="1">
-                <a:solidFill>
-                  <a:srgbClr val="595959"/>
-                </a:solidFill>
-                <a:latin typeface="Arial"/>
-                <a:ea typeface="Arial"/>
-                <a:cs typeface="Arial"/>
-              </a:defRPr>
-            </a:lvl9pPr>
-          </a:lstStyle>
-          <a:p xmlns:a="http://schemas.openxmlformats.org/drawingml/2006/main">
-            <a:pPr algn="l">
-              <a:defRPr sz="1200" b="1">
-                <a:solidFill>
-                  <a:srgbClr val="595959"/>
-                </a:solidFill>
-                <a:latin typeface="Arial"/>
-                <a:ea typeface="Arial"/>
-                <a:cs typeface="Arial"/>
-              </a:defRPr>
-            </a:pPr>
-            <a:r>
-              <a:rPr sz="1200" b="1">
-                <a:solidFill>
-                  <a:srgbClr val="595959"/>
-                </a:solidFill>
-                <a:latin typeface="Arial"/>
-                <a:ea typeface="Arial"/>
-                <a:cs typeface="Arial"/>
-              </a:rPr>
-              <a:t>РАНЬШЕ</a:t>
-            </a:r>
-          </a:p>
-        </p:txBody>
-      </p:sp>
-      <p:sp>
-        <p:nvSpPr>
-          <p:cNvPr id="71" name="before text">
-            <a:extLst xmlns:a="http://schemas.openxmlformats.org/drawingml/2006/main">
-              <a:ext uri="{FF2B5EF4-FFF2-40B4-BE49-F238E27FC236}">
-                <a16:creationId xmlns:a16="http://schemas.microsoft.com/office/drawing/2014/main" id="{4E2DEBC6-36DB-44FC-B149-1A95E0B2F056}"/>
-              </a:ext>
-            </a:extLst>
-          </p:cNvPr>
-          <p:cNvSpPr>
-            <a:spLocks xmlns:a="http://schemas.openxmlformats.org/drawingml/2006/main" noGrp="1"/>
-          </p:cNvSpPr>
-          <p:nvPr/>
-        </p:nvSpPr>
-        <p:spPr>
-          <a:xfrm xmlns:a="http://schemas.openxmlformats.org/drawingml/2006/main">
-            <a:off x="400050" y="1876425"/>
-            <a:ext cx="3857625" cy="904875"/>
-          </a:xfrm>
-          <a:prstGeom xmlns:a="http://schemas.openxmlformats.org/drawingml/2006/main" prst="rect">
-            <a:avLst/>
-          </a:prstGeom>
-          <a:noFill xmlns:a="http://schemas.openxmlformats.org/drawingml/2006/main"/>
-          <a:ln xmlns:a="http://schemas.openxmlformats.org/drawingml/2006/main" w="0">
-            <a:noFill/>
-            <a:prstDash val="solid"/>
-          </a:ln>
-        </p:spPr>
-        <p:txBody>
-          <a:bodyPr xmlns:a="http://schemas.openxmlformats.org/drawingml/2006/main" wrap="square" lIns="0" tIns="0" rIns="0" bIns="0" anchor="t">
-            <a:noAutofit/>
-          </a:bodyPr>
-          <a:lstStyle xmlns:a="http://schemas.openxmlformats.org/drawingml/2006/main">
-            <a:defPPr algn="l">
-              <a:defRPr sz="1650" b="0">
-                <a:solidFill>
-                  <a:srgbClr val="595959"/>
-                </a:solidFill>
-                <a:latin typeface="Arial"/>
-                <a:ea typeface="Arial"/>
-                <a:cs typeface="Arial"/>
-              </a:defRPr>
-            </a:defPPr>
-            <a:lvl1pPr algn="l">
-              <a:defRPr sz="1650" b="0">
-                <a:solidFill>
-                  <a:srgbClr val="595959"/>
-                </a:solidFill>
-                <a:latin typeface="Arial"/>
-                <a:ea typeface="Arial"/>
-                <a:cs typeface="Arial"/>
-              </a:defRPr>
-            </a:lvl1pPr>
-            <a:lvl2pPr algn="l">
-              <a:defRPr sz="1650" b="0">
-                <a:solidFill>
-                  <a:srgbClr val="595959"/>
-                </a:solidFill>
-                <a:latin typeface="Arial"/>
-                <a:ea typeface="Arial"/>
-                <a:cs typeface="Arial"/>
-              </a:defRPr>
-            </a:lvl2pPr>
-            <a:lvl3pPr algn="l">
-              <a:defRPr sz="1650" b="0">
-                <a:solidFill>
-                  <a:srgbClr val="595959"/>
-                </a:solidFill>
-                <a:latin typeface="Arial"/>
-                <a:ea typeface="Arial"/>
-                <a:cs typeface="Arial"/>
-              </a:defRPr>
-            </a:lvl3pPr>
-            <a:lvl4pPr algn="l">
-              <a:defRPr sz="1650" b="0">
-                <a:solidFill>
-                  <a:srgbClr val="595959"/>
-                </a:solidFill>
-                <a:latin typeface="Arial"/>
-                <a:ea typeface="Arial"/>
-                <a:cs typeface="Arial"/>
-              </a:defRPr>
-            </a:lvl4pPr>
-            <a:lvl5pPr algn="l">
-              <a:defRPr sz="1650" b="0">
-                <a:solidFill>
-                  <a:srgbClr val="595959"/>
-                </a:solidFill>
-                <a:latin typeface="Arial"/>
-                <a:ea typeface="Arial"/>
-                <a:cs typeface="Arial"/>
-              </a:defRPr>
-            </a:lvl5pPr>
-            <a:lvl6pPr algn="l">
-              <a:defRPr sz="1650" b="0">
-                <a:solidFill>
-                  <a:srgbClr val="595959"/>
-                </a:solidFill>
-                <a:latin typeface="Arial"/>
-                <a:ea typeface="Arial"/>
-                <a:cs typeface="Arial"/>
-              </a:defRPr>
-            </a:lvl6pPr>
-            <a:lvl7pPr algn="l">
-              <a:defRPr sz="1650" b="0">
-                <a:solidFill>
-                  <a:srgbClr val="595959"/>
-                </a:solidFill>
-                <a:latin typeface="Arial"/>
-                <a:ea typeface="Arial"/>
-                <a:cs typeface="Arial"/>
-              </a:defRPr>
-            </a:lvl7pPr>
-            <a:lvl8pPr algn="l">
-              <a:defRPr sz="1650" b="0">
-                <a:solidFill>
-                  <a:srgbClr val="595959"/>
-                </a:solidFill>
-                <a:latin typeface="Arial"/>
-                <a:ea typeface="Arial"/>
-                <a:cs typeface="Arial"/>
-              </a:defRPr>
-            </a:lvl8pPr>
-            <a:lvl9pPr algn="l">
-              <a:defRPr sz="1650" b="0">
-                <a:solidFill>
-                  <a:srgbClr val="595959"/>
-                </a:solidFill>
-                <a:latin typeface="Arial"/>
-                <a:ea typeface="Arial"/>
-                <a:cs typeface="Arial"/>
-              </a:defRPr>
-            </a:lvl9pPr>
-          </a:lstStyle>
-          <a:p xmlns:a="http://schemas.openxmlformats.org/drawingml/2006/main">
-            <a:pPr algn="l">
-              <a:defRPr sz="1650" b="0">
-                <a:solidFill>
-                  <a:srgbClr val="595959"/>
-                </a:solidFill>
-                <a:latin typeface="Arial"/>
-                <a:ea typeface="Arial"/>
-                <a:cs typeface="Arial"/>
-              </a:defRPr>
-            </a:pPr>
-            <a:r>
-              <a:rPr sz="1650" b="0">
-                <a:solidFill>
-                  <a:srgbClr val="595959"/>
-                </a:solidFill>
-                <a:latin typeface="Arial"/>
-                <a:ea typeface="Arial"/>
-                <a:cs typeface="Arial"/>
-              </a:rPr>
-              <a:t>Зафиксировать передачу смены в журнале и указать следующего сотрудника.</a:t>
-            </a:r>
-          </a:p>
-        </p:txBody>
-      </p:sp>
-      <p:sp>
-        <p:nvSpPr>
-          <p:cNvPr id="72" name="before now divider">
-            <a:extLst xmlns:a="http://schemas.openxmlformats.org/drawingml/2006/main">
-              <a:ext uri="{FF2B5EF4-FFF2-40B4-BE49-F238E27FC236}">
-                <a16:creationId xmlns:a16="http://schemas.microsoft.com/office/drawing/2014/main" id="{7C22B58B-3EE4-47CA-A89F-CB4699D1B3DA}"/>
-              </a:ext>
-            </a:extLst>
-          </p:cNvPr>
-          <p:cNvSpPr>
-            <a:spLocks xmlns:a="http://schemas.openxmlformats.org/drawingml/2006/main" noGrp="1"/>
-          </p:cNvSpPr>
-          <p:nvPr/>
-        </p:nvSpPr>
-        <p:spPr>
-          <a:xfrm xmlns:a="http://schemas.openxmlformats.org/drawingml/2006/main">
-            <a:off x="4562475" y="1543050"/>
-            <a:ext cx="9525" cy="1362075"/>
-          </a:xfrm>
-          <a:prstGeom xmlns:a="http://schemas.openxmlformats.org/drawingml/2006/main" prst="rect">
-            <a:avLst/>
-          </a:prstGeom>
-          <a:solidFill xmlns:a="http://schemas.openxmlformats.org/drawingml/2006/main">
-            <a:srgbClr val="D5D5D5"/>
-          </a:solidFill>
-          <a:ln xmlns:a="http://schemas.openxmlformats.org/drawingml/2006/main" w="0">
-            <a:noFill/>
-            <a:prstDash val="solid"/>
-          </a:ln>
-        </p:spPr>
-      </p:sp>
-      <p:sp>
-        <p:nvSpPr>
-          <p:cNvPr id="73" name="now label">
-            <a:extLst xmlns:a="http://schemas.openxmlformats.org/drawingml/2006/main">
-              <a:ext uri="{FF2B5EF4-FFF2-40B4-BE49-F238E27FC236}">
-                <a16:creationId xmlns:a16="http://schemas.microsoft.com/office/drawing/2014/main" id="{6AB2E8C5-CCCF-4CE5-A0CD-FD5575ACCE41}"/>
-              </a:ext>
-            </a:extLst>
-          </p:cNvPr>
-          <p:cNvSpPr>
-            <a:spLocks xmlns:a="http://schemas.openxmlformats.org/drawingml/2006/main" noGrp="1"/>
-          </p:cNvSpPr>
-          <p:nvPr/>
-        </p:nvSpPr>
-        <p:spPr>
-          <a:xfrm xmlns:a="http://schemas.openxmlformats.org/drawingml/2006/main">
-            <a:off x="4876800" y="1571625"/>
-            <a:ext cx="3867150" cy="228600"/>
-          </a:xfrm>
-          <a:prstGeom xmlns:a="http://schemas.openxmlformats.org/drawingml/2006/main" prst="rect">
-            <a:avLst/>
-          </a:prstGeom>
-          <a:noFill xmlns:a="http://schemas.openxmlformats.org/drawingml/2006/main"/>
-          <a:ln xmlns:a="http://schemas.openxmlformats.org/drawingml/2006/main" w="0">
-            <a:noFill/>
-            <a:prstDash val="solid"/>
-          </a:ln>
-        </p:spPr>
-        <p:txBody>
-          <a:bodyPr xmlns:a="http://schemas.openxmlformats.org/drawingml/2006/main" wrap="square" lIns="0" tIns="0" rIns="0" bIns="0" anchor="t">
-            <a:noAutofit/>
-          </a:bodyPr>
-          <a:lstStyle xmlns:a="http://schemas.openxmlformats.org/drawingml/2006/main">
-            <a:defPPr algn="l">
-              <a:defRPr sz="1200" b="1">
-                <a:solidFill>
-                  <a:srgbClr val="595959"/>
-                </a:solidFill>
-                <a:latin typeface="Arial"/>
-                <a:ea typeface="Arial"/>
-                <a:cs typeface="Arial"/>
-              </a:defRPr>
-            </a:defPPr>
-            <a:lvl1pPr algn="l">
-              <a:defRPr sz="1200" b="1">
-                <a:solidFill>
-                  <a:srgbClr val="595959"/>
-                </a:solidFill>
-                <a:latin typeface="Arial"/>
-                <a:ea typeface="Arial"/>
-                <a:cs typeface="Arial"/>
-              </a:defRPr>
-            </a:lvl1pPr>
-            <a:lvl2pPr algn="l">
-              <a:defRPr sz="1200" b="1">
-                <a:solidFill>
-                  <a:srgbClr val="595959"/>
-                </a:solidFill>
-                <a:latin typeface="Arial"/>
-                <a:ea typeface="Arial"/>
-                <a:cs typeface="Arial"/>
-              </a:defRPr>
-            </a:lvl2pPr>
-            <a:lvl3pPr algn="l">
-              <a:defRPr sz="1200" b="1">
-                <a:solidFill>
-                  <a:srgbClr val="595959"/>
-                </a:solidFill>
-                <a:latin typeface="Arial"/>
-                <a:ea typeface="Arial"/>
-                <a:cs typeface="Arial"/>
-              </a:defRPr>
-            </a:lvl3pPr>
-            <a:lvl4pPr algn="l">
-              <a:defRPr sz="1200" b="1">
-                <a:solidFill>
-                  <a:srgbClr val="595959"/>
-                </a:solidFill>
-                <a:latin typeface="Arial"/>
-                <a:ea typeface="Arial"/>
-                <a:cs typeface="Arial"/>
-              </a:defRPr>
-            </a:lvl4pPr>
-            <a:lvl5pPr algn="l">
-              <a:defRPr sz="1200" b="1">
-                <a:solidFill>
-                  <a:srgbClr val="595959"/>
-                </a:solidFill>
-                <a:latin typeface="Arial"/>
-                <a:ea typeface="Arial"/>
-                <a:cs typeface="Arial"/>
-              </a:defRPr>
-            </a:lvl5pPr>
-            <a:lvl6pPr algn="l">
-              <a:defRPr sz="1200" b="1">
-                <a:solidFill>
-                  <a:srgbClr val="595959"/>
-                </a:solidFill>
-                <a:latin typeface="Arial"/>
-                <a:ea typeface="Arial"/>
-                <a:cs typeface="Arial"/>
-              </a:defRPr>
-            </a:lvl6pPr>
-            <a:lvl7pPr algn="l">
-              <a:defRPr sz="1200" b="1">
-                <a:solidFill>
-                  <a:srgbClr val="595959"/>
-                </a:solidFill>
-                <a:latin typeface="Arial"/>
-                <a:ea typeface="Arial"/>
-                <a:cs typeface="Arial"/>
-              </a:defRPr>
-            </a:lvl7pPr>
-            <a:lvl8pPr algn="l">
-              <a:defRPr sz="1200" b="1">
-                <a:solidFill>
-                  <a:srgbClr val="595959"/>
-                </a:solidFill>
-                <a:latin typeface="Arial"/>
-                <a:ea typeface="Arial"/>
-                <a:cs typeface="Arial"/>
-              </a:defRPr>
-            </a:lvl8pPr>
-            <a:lvl9pPr algn="l">
-              <a:defRPr sz="1200" b="1">
-                <a:solidFill>
-                  <a:srgbClr val="595959"/>
-                </a:solidFill>
-                <a:latin typeface="Arial"/>
-                <a:ea typeface="Arial"/>
-                <a:cs typeface="Arial"/>
-              </a:defRPr>
-            </a:lvl9pPr>
-          </a:lstStyle>
-          <a:p xmlns:a="http://schemas.openxmlformats.org/drawingml/2006/main">
-            <a:pPr algn="l">
-              <a:defRPr sz="1200" b="1">
-                <a:solidFill>
-                  <a:srgbClr val="595959"/>
-                </a:solidFill>
-                <a:latin typeface="Arial"/>
-                <a:ea typeface="Arial"/>
-                <a:cs typeface="Arial"/>
-              </a:defRPr>
-            </a:pPr>
-            <a:r>
-              <a:rPr sz="1200" b="1">
-                <a:solidFill>
-                  <a:srgbClr val="595959"/>
-                </a:solidFill>
-                <a:latin typeface="Arial"/>
-                <a:ea typeface="Arial"/>
-                <a:cs typeface="Arial"/>
-              </a:rPr>
-              <a:t>ТЕПЕРЬ</a:t>
-            </a:r>
-          </a:p>
-        </p:txBody>
-      </p:sp>
-      <p:sp>
-        <p:nvSpPr>
-          <p:cNvPr id="74" name="now text">
-            <a:extLst xmlns:a="http://schemas.openxmlformats.org/drawingml/2006/main">
-              <a:ext uri="{FF2B5EF4-FFF2-40B4-BE49-F238E27FC236}">
-                <a16:creationId xmlns:a16="http://schemas.microsoft.com/office/drawing/2014/main" id="{6146572A-39A6-4956-8C98-719AD0200EDD}"/>
-              </a:ext>
-            </a:extLst>
-          </p:cNvPr>
-          <p:cNvSpPr>
-            <a:spLocks xmlns:a="http://schemas.openxmlformats.org/drawingml/2006/main" noGrp="1"/>
-          </p:cNvSpPr>
-          <p:nvPr/>
-        </p:nvSpPr>
-        <p:spPr>
-          <a:xfrm xmlns:a="http://schemas.openxmlformats.org/drawingml/2006/main">
-            <a:off x="4876800" y="1876425"/>
-            <a:ext cx="3867150" cy="904875"/>
-          </a:xfrm>
-          <a:prstGeom xmlns:a="http://schemas.openxmlformats.org/drawingml/2006/main" prst="rect">
-            <a:avLst/>
-          </a:prstGeom>
-          <a:noFill xmlns:a="http://schemas.openxmlformats.org/drawingml/2006/main"/>
-          <a:ln xmlns:a="http://schemas.openxmlformats.org/drawingml/2006/main" w="0">
-            <a:noFill/>
-            <a:prstDash val="solid"/>
-          </a:ln>
-        </p:spPr>
-        <p:txBody>
-          <a:bodyPr xmlns:a="http://schemas.openxmlformats.org/drawingml/2006/main" wrap="square" lIns="0" tIns="0" rIns="0" bIns="0" anchor="t">
-            <a:noAutofit/>
-          </a:bodyPr>
-          <a:lstStyle xmlns:a="http://schemas.openxmlformats.org/drawingml/2006/main">
-            <a:defPPr algn="l">
-              <a:defRPr sz="1650" b="0">
-                <a:solidFill>
-                  <a:srgbClr val="111111"/>
-                </a:solidFill>
-                <a:latin typeface="Arial"/>
-                <a:ea typeface="Arial"/>
-                <a:cs typeface="Arial"/>
-              </a:defRPr>
-            </a:defPPr>
-            <a:lvl1pPr algn="l">
-              <a:defRPr sz="1650" b="0">
-                <a:solidFill>
-                  <a:srgbClr val="111111"/>
-                </a:solidFill>
-                <a:latin typeface="Arial"/>
-                <a:ea typeface="Arial"/>
-                <a:cs typeface="Arial"/>
-              </a:defRPr>
-            </a:lvl1pPr>
-            <a:lvl2pPr algn="l">
-              <a:defRPr sz="1650" b="0">
-                <a:solidFill>
-                  <a:srgbClr val="111111"/>
-                </a:solidFill>
-                <a:latin typeface="Arial"/>
-                <a:ea typeface="Arial"/>
-                <a:cs typeface="Arial"/>
-              </a:defRPr>
-            </a:lvl2pPr>
-            <a:lvl3pPr algn="l">
-              <a:defRPr sz="1650" b="0">
-                <a:solidFill>
-                  <a:srgbClr val="111111"/>
-                </a:solidFill>
-                <a:latin typeface="Arial"/>
-                <a:ea typeface="Arial"/>
-                <a:cs typeface="Arial"/>
-              </a:defRPr>
-            </a:lvl3pPr>
-            <a:lvl4pPr algn="l">
-              <a:defRPr sz="1650" b="0">
-                <a:solidFill>
-                  <a:srgbClr val="111111"/>
-                </a:solidFill>
-                <a:latin typeface="Arial"/>
-                <a:ea typeface="Arial"/>
-                <a:cs typeface="Arial"/>
-              </a:defRPr>
-            </a:lvl4pPr>
-            <a:lvl5pPr algn="l">
-              <a:defRPr sz="1650" b="0">
-                <a:solidFill>
-                  <a:srgbClr val="111111"/>
-                </a:solidFill>
-                <a:latin typeface="Arial"/>
-                <a:ea typeface="Arial"/>
-                <a:cs typeface="Arial"/>
-              </a:defRPr>
-            </a:lvl5pPr>
-            <a:lvl6pPr algn="l">
-              <a:defRPr sz="1650" b="0">
-                <a:solidFill>
-                  <a:srgbClr val="111111"/>
-                </a:solidFill>
-                <a:latin typeface="Arial"/>
-                <a:ea typeface="Arial"/>
-                <a:cs typeface="Arial"/>
-              </a:defRPr>
-            </a:lvl6pPr>
-            <a:lvl7pPr algn="l">
-              <a:defRPr sz="1650" b="0">
-                <a:solidFill>
-                  <a:srgbClr val="111111"/>
-                </a:solidFill>
-                <a:latin typeface="Arial"/>
-                <a:ea typeface="Arial"/>
-                <a:cs typeface="Arial"/>
-              </a:defRPr>
-            </a:lvl7pPr>
-            <a:lvl8pPr algn="l">
-              <a:defRPr sz="1650" b="0">
-                <a:solidFill>
-                  <a:srgbClr val="111111"/>
-                </a:solidFill>
-                <a:latin typeface="Arial"/>
-                <a:ea typeface="Arial"/>
-                <a:cs typeface="Arial"/>
-              </a:defRPr>
-            </a:lvl8pPr>
-            <a:lvl9pPr algn="l">
-              <a:defRPr sz="1650" b="0">
-                <a:solidFill>
-                  <a:srgbClr val="111111"/>
-                </a:solidFill>
-                <a:latin typeface="Arial"/>
-                <a:ea typeface="Arial"/>
-                <a:cs typeface="Arial"/>
-              </a:defRPr>
-            </a:lvl9pPr>
-          </a:lstStyle>
-          <a:p xmlns:a="http://schemas.openxmlformats.org/drawingml/2006/main">
-            <a:pPr algn="l">
-              <a:defRPr sz="1650" b="0">
-                <a:solidFill>
-                  <a:srgbClr val="111111"/>
-                </a:solidFill>
-                <a:latin typeface="Arial"/>
-                <a:ea typeface="Arial"/>
-                <a:cs typeface="Arial"/>
-              </a:defRPr>
-            </a:pPr>
-            <a:r>
-              <a:rPr sz="1650" b="0">
-                <a:solidFill>
-                  <a:srgbClr val="111111"/>
-                </a:solidFill>
-                <a:latin typeface="Arial"/>
-                <a:ea typeface="Arial"/>
-                <a:cs typeface="Arial"/>
-              </a:rPr>
-              <a:t>Если принимающий опаздывает, оставить запись открытой до подтверждения.</a:t>
-            </a:r>
-          </a:p>
-        </p:txBody>
-      </p:sp>
-      <p:sp>
-        <p:nvSpPr>
-          <p:cNvPr id="75" name="question divider">
-            <a:extLst xmlns:a="http://schemas.openxmlformats.org/drawingml/2006/main">
-              <a:ext uri="{FF2B5EF4-FFF2-40B4-BE49-F238E27FC236}">
-                <a16:creationId xmlns:a16="http://schemas.microsoft.com/office/drawing/2014/main" id="{A73D7CB6-57EC-4975-8A29-AABCC69F4D1A}"/>
-              </a:ext>
-            </a:extLst>
-          </p:cNvPr>
-          <p:cNvSpPr>
-            <a:spLocks xmlns:a="http://schemas.openxmlformats.org/drawingml/2006/main" noGrp="1"/>
-          </p:cNvSpPr>
-          <p:nvPr/>
-        </p:nvSpPr>
-        <p:spPr>
-          <a:xfrm xmlns:a="http://schemas.openxmlformats.org/drawingml/2006/main">
-            <a:off x="400050" y="3067050"/>
-            <a:ext cx="8343900" cy="9525"/>
-          </a:xfrm>
-          <a:prstGeom xmlns:a="http://schemas.openxmlformats.org/drawingml/2006/main" prst="rect">
-            <a:avLst/>
-          </a:prstGeom>
-          <a:solidFill xmlns:a="http://schemas.openxmlformats.org/drawingml/2006/main">
-            <a:srgbClr val="D5D5D5"/>
-          </a:solidFill>
-          <a:ln xmlns:a="http://schemas.openxmlformats.org/drawingml/2006/main" w="0">
-            <a:noFill/>
-            <a:prstDash val="solid"/>
-          </a:ln>
-        </p:spPr>
-      </p:sp>
-      <p:sp>
-        <p:nvSpPr>
-          <p:cNvPr id="76" name="quiz label">
-            <a:extLst xmlns:a="http://schemas.openxmlformats.org/drawingml/2006/main">
-              <a:ext uri="{FF2B5EF4-FFF2-40B4-BE49-F238E27FC236}">
-                <a16:creationId xmlns:a16="http://schemas.microsoft.com/office/drawing/2014/main" id="{951250EB-49AC-43DF-A12A-E399FC3C02F7}"/>
-              </a:ext>
-            </a:extLst>
-          </p:cNvPr>
-          <p:cNvSpPr>
-            <a:spLocks xmlns:a="http://schemas.openxmlformats.org/drawingml/2006/main" noGrp="1"/>
-          </p:cNvSpPr>
-          <p:nvPr/>
-        </p:nvSpPr>
-        <p:spPr>
-          <a:xfrm xmlns:a="http://schemas.openxmlformats.org/drawingml/2006/main">
-            <a:off x="400050" y="3238500"/>
-            <a:ext cx="8343900" cy="190500"/>
-          </a:xfrm>
-          <a:prstGeom xmlns:a="http://schemas.openxmlformats.org/drawingml/2006/main" prst="rect">
-            <a:avLst/>
-          </a:prstGeom>
-          <a:noFill xmlns:a="http://schemas.openxmlformats.org/drawingml/2006/main"/>
-          <a:ln xmlns:a="http://schemas.openxmlformats.org/drawingml/2006/main" w="0">
-            <a:noFill/>
-            <a:prstDash val="solid"/>
-          </a:ln>
-        </p:spPr>
-        <p:txBody>
-          <a:bodyPr xmlns:a="http://schemas.openxmlformats.org/drawingml/2006/main" wrap="square" lIns="0" tIns="0" rIns="0" bIns="0" anchor="t">
-            <a:noAutofit/>
-          </a:bodyPr>
-          <a:lstStyle xmlns:a="http://schemas.openxmlformats.org/drawingml/2006/main">
-            <a:defPPr algn="l">
-              <a:defRPr sz="1125" b="1">
-                <a:solidFill>
-                  <a:srgbClr val="595959"/>
-                </a:solidFill>
-                <a:latin typeface="Arial"/>
-                <a:ea typeface="Arial"/>
-                <a:cs typeface="Arial"/>
-              </a:defRPr>
-            </a:defPPr>
-            <a:lvl1pPr algn="l">
-              <a:defRPr sz="1125" b="1">
-                <a:solidFill>
-                  <a:srgbClr val="595959"/>
-                </a:solidFill>
-                <a:latin typeface="Arial"/>
-                <a:ea typeface="Arial"/>
-                <a:cs typeface="Arial"/>
-              </a:defRPr>
-            </a:lvl1pPr>
-            <a:lvl2pPr algn="l">
-              <a:defRPr sz="1125" b="1">
-                <a:solidFill>
-                  <a:srgbClr val="595959"/>
-                </a:solidFill>
-                <a:latin typeface="Arial"/>
-                <a:ea typeface="Arial"/>
-                <a:cs typeface="Arial"/>
-              </a:defRPr>
-            </a:lvl2pPr>
-            <a:lvl3pPr algn="l">
-              <a:defRPr sz="1125" b="1">
-                <a:solidFill>
-                  <a:srgbClr val="595959"/>
-                </a:solidFill>
-                <a:latin typeface="Arial"/>
-                <a:ea typeface="Arial"/>
-                <a:cs typeface="Arial"/>
-              </a:defRPr>
-            </a:lvl3pPr>
-            <a:lvl4pPr algn="l">
-              <a:defRPr sz="1125" b="1">
-                <a:solidFill>
-                  <a:srgbClr val="595959"/>
-                </a:solidFill>
-                <a:latin typeface="Arial"/>
-                <a:ea typeface="Arial"/>
-                <a:cs typeface="Arial"/>
-              </a:defRPr>
-            </a:lvl4pPr>
-            <a:lvl5pPr algn="l">
-              <a:defRPr sz="1125" b="1">
-                <a:solidFill>
-                  <a:srgbClr val="595959"/>
-                </a:solidFill>
-                <a:latin typeface="Arial"/>
-                <a:ea typeface="Arial"/>
-                <a:cs typeface="Arial"/>
-              </a:defRPr>
-            </a:lvl5pPr>
-            <a:lvl6pPr algn="l">
-              <a:defRPr sz="1125" b="1">
-                <a:solidFill>
-                  <a:srgbClr val="595959"/>
-                </a:solidFill>
-                <a:latin typeface="Arial"/>
-                <a:ea typeface="Arial"/>
-                <a:cs typeface="Arial"/>
-              </a:defRPr>
-            </a:lvl6pPr>
-            <a:lvl7pPr algn="l">
-              <a:defRPr sz="1125" b="1">
-                <a:solidFill>
-                  <a:srgbClr val="595959"/>
-                </a:solidFill>
-                <a:latin typeface="Arial"/>
-                <a:ea typeface="Arial"/>
-                <a:cs typeface="Arial"/>
-              </a:defRPr>
-            </a:lvl7pPr>
-            <a:lvl8pPr algn="l">
-              <a:defRPr sz="1125" b="1">
-                <a:solidFill>
-                  <a:srgbClr val="595959"/>
-                </a:solidFill>
-                <a:latin typeface="Arial"/>
-                <a:ea typeface="Arial"/>
-                <a:cs typeface="Arial"/>
-              </a:defRPr>
-            </a:lvl8pPr>
-            <a:lvl9pPr algn="l">
-              <a:defRPr sz="1125" b="1">
-                <a:solidFill>
-                  <a:srgbClr val="595959"/>
-                </a:solidFill>
-                <a:latin typeface="Arial"/>
-                <a:ea typeface="Arial"/>
-                <a:cs typeface="Arial"/>
-              </a:defRPr>
-            </a:lvl9pPr>
-          </a:lstStyle>
-          <a:p xmlns:a="http://schemas.openxmlformats.org/drawingml/2006/main">
-            <a:pPr algn="l">
-              <a:defRPr sz="1125" b="1">
-                <a:solidFill>
-                  <a:srgbClr val="595959"/>
-                </a:solidFill>
-                <a:latin typeface="Arial"/>
-                <a:ea typeface="Arial"/>
-                <a:cs typeface="Arial"/>
-              </a:defRPr>
-            </a:pPr>
-            <a:r>
-              <a:rPr sz="1125" b="1">
-                <a:solidFill>
-                  <a:srgbClr val="595959"/>
-                </a:solidFill>
-                <a:latin typeface="Arial"/>
-                <a:ea typeface="Arial"/>
-                <a:cs typeface="Arial"/>
-              </a:rPr>
-              <a:t>ВОПРОС СОТРУДНИКУ</a:t>
-            </a:r>
-          </a:p>
-        </p:txBody>
-      </p:sp>
-      <p:sp>
-        <p:nvSpPr>
-          <p:cNvPr id="77" name="quiz">
-            <a:extLst xmlns:a="http://schemas.openxmlformats.org/drawingml/2006/main">
-              <a:ext uri="{FF2B5EF4-FFF2-40B4-BE49-F238E27FC236}">
-                <a16:creationId xmlns:a16="http://schemas.microsoft.com/office/drawing/2014/main" id="{AB846B64-C03D-4EED-ABA2-569EEECFD234}"/>
-              </a:ext>
-            </a:extLst>
-          </p:cNvPr>
-          <p:cNvSpPr>
-            <a:spLocks xmlns:a="http://schemas.openxmlformats.org/drawingml/2006/main" noGrp="1"/>
-          </p:cNvSpPr>
-          <p:nvPr/>
-        </p:nvSpPr>
-        <p:spPr>
-          <a:xfrm xmlns:a="http://schemas.openxmlformats.org/drawingml/2006/main">
-            <a:off x="400050" y="3486150"/>
-            <a:ext cx="8343900" cy="333375"/>
-          </a:xfrm>
-          <a:prstGeom xmlns:a="http://schemas.openxmlformats.org/drawingml/2006/main" prst="rect">
-            <a:avLst/>
-          </a:prstGeom>
-          <a:noFill xmlns:a="http://schemas.openxmlformats.org/drawingml/2006/main"/>
-          <a:ln xmlns:a="http://schemas.openxmlformats.org/drawingml/2006/main" w="0">
-            <a:noFill/>
-            <a:prstDash val="solid"/>
-          </a:ln>
-        </p:spPr>
-        <p:txBody>
-          <a:bodyPr xmlns:a="http://schemas.openxmlformats.org/drawingml/2006/main" wrap="square" lIns="0" tIns="0" rIns="0" bIns="0" anchor="t">
-            <a:noAutofit/>
-          </a:bodyPr>
-          <a:lstStyle xmlns:a="http://schemas.openxmlformats.org/drawingml/2006/main">
-            <a:defPPr algn="l">
-              <a:defRPr sz="1650" b="0">
-                <a:solidFill>
-                  <a:srgbClr val="111111"/>
-                </a:solidFill>
-                <a:latin typeface="Arial"/>
-                <a:ea typeface="Arial"/>
-                <a:cs typeface="Arial"/>
-              </a:defRPr>
-            </a:defPPr>
-            <a:lvl1pPr algn="l">
-              <a:defRPr sz="1650" b="0">
-                <a:solidFill>
-                  <a:srgbClr val="111111"/>
-                </a:solidFill>
-                <a:latin typeface="Arial"/>
-                <a:ea typeface="Arial"/>
-                <a:cs typeface="Arial"/>
-              </a:defRPr>
-            </a:lvl1pPr>
-            <a:lvl2pPr algn="l">
-              <a:defRPr sz="1650" b="0">
-                <a:solidFill>
-                  <a:srgbClr val="111111"/>
-                </a:solidFill>
-                <a:latin typeface="Arial"/>
-                <a:ea typeface="Arial"/>
-                <a:cs typeface="Arial"/>
-              </a:defRPr>
-            </a:lvl2pPr>
-            <a:lvl3pPr algn="l">
-              <a:defRPr sz="1650" b="0">
-                <a:solidFill>
-                  <a:srgbClr val="111111"/>
-                </a:solidFill>
-                <a:latin typeface="Arial"/>
-                <a:ea typeface="Arial"/>
-                <a:cs typeface="Arial"/>
-              </a:defRPr>
-            </a:lvl3pPr>
-            <a:lvl4pPr algn="l">
-              <a:defRPr sz="1650" b="0">
-                <a:solidFill>
-                  <a:srgbClr val="111111"/>
-                </a:solidFill>
-                <a:latin typeface="Arial"/>
-                <a:ea typeface="Arial"/>
-                <a:cs typeface="Arial"/>
-              </a:defRPr>
-            </a:lvl4pPr>
-            <a:lvl5pPr algn="l">
-              <a:defRPr sz="1650" b="0">
-                <a:solidFill>
-                  <a:srgbClr val="111111"/>
-                </a:solidFill>
-                <a:latin typeface="Arial"/>
-                <a:ea typeface="Arial"/>
-                <a:cs typeface="Arial"/>
-              </a:defRPr>
-            </a:lvl5pPr>
-            <a:lvl6pPr algn="l">
-              <a:defRPr sz="1650" b="0">
-                <a:solidFill>
-                  <a:srgbClr val="111111"/>
-                </a:solidFill>
-                <a:latin typeface="Arial"/>
-                <a:ea typeface="Arial"/>
-                <a:cs typeface="Arial"/>
-              </a:defRPr>
-            </a:lvl6pPr>
-            <a:lvl7pPr algn="l">
-              <a:defRPr sz="1650" b="0">
-                <a:solidFill>
-                  <a:srgbClr val="111111"/>
-                </a:solidFill>
-                <a:latin typeface="Arial"/>
-                <a:ea typeface="Arial"/>
-                <a:cs typeface="Arial"/>
-              </a:defRPr>
-            </a:lvl7pPr>
-            <a:lvl8pPr algn="l">
-              <a:defRPr sz="1650" b="0">
-                <a:solidFill>
-                  <a:srgbClr val="111111"/>
-                </a:solidFill>
-                <a:latin typeface="Arial"/>
-                <a:ea typeface="Arial"/>
-                <a:cs typeface="Arial"/>
-              </a:defRPr>
-            </a:lvl8pPr>
-            <a:lvl9pPr algn="l">
-              <a:defRPr sz="1650" b="0">
-                <a:solidFill>
-                  <a:srgbClr val="111111"/>
-                </a:solidFill>
-                <a:latin typeface="Arial"/>
-                <a:ea typeface="Arial"/>
-                <a:cs typeface="Arial"/>
-              </a:defRPr>
-            </a:lvl9pPr>
-          </a:lstStyle>
-          <a:p xmlns:a="http://schemas.openxmlformats.org/drawingml/2006/main">
-            <a:pPr algn="l">
-              <a:defRPr sz="1650" b="0">
-                <a:solidFill>
-                  <a:srgbClr val="111111"/>
-                </a:solidFill>
-                <a:latin typeface="Arial"/>
-                <a:ea typeface="Arial"/>
-                <a:cs typeface="Arial"/>
-              </a:defRPr>
-            </a:pPr>
-            <a:r>
-              <a:rPr sz="1650" b="0">
-                <a:solidFill>
-                  <a:srgbClr val="111111"/>
-                </a:solidFill>
-                <a:latin typeface="Arial"/>
-                <a:ea typeface="Arial"/>
-                <a:cs typeface="Arial"/>
-              </a:rPr>
-              <a:t>Когда закрыть запись, если коллега ещё не подтвердил смену?</a:t>
-            </a:r>
-          </a:p>
-        </p:txBody>
-      </p:sp>
-      <p:sp>
-        <p:nvSpPr>
-          <p:cNvPr id="78" name="workflow">
-            <a:extLst xmlns:a="http://schemas.openxmlformats.org/drawingml/2006/main">
-              <a:ext uri="{FF2B5EF4-FFF2-40B4-BE49-F238E27FC236}">
-                <a16:creationId xmlns:a16="http://schemas.microsoft.com/office/drawing/2014/main" id="{AEC24773-9C17-44C1-B709-780B7B21A7B0}"/>
-              </a:ext>
-            </a:extLst>
-          </p:cNvPr>
-          <p:cNvSpPr>
-            <a:spLocks xmlns:a="http://schemas.openxmlformats.org/drawingml/2006/main" noGrp="1"/>
-          </p:cNvSpPr>
-          <p:nvPr/>
-        </p:nvSpPr>
-        <p:spPr>
-          <a:xfrm xmlns:a="http://schemas.openxmlformats.org/drawingml/2006/main">
-            <a:off x="400050" y="4171950"/>
-            <a:ext cx="8343900" cy="400050"/>
-          </a:xfrm>
-          <a:prstGeom xmlns:a="http://schemas.openxmlformats.org/drawingml/2006/main" prst="rect">
-            <a:avLst/>
-          </a:prstGeom>
-          <a:noFill xmlns:a="http://schemas.openxmlformats.org/drawingml/2006/main"/>
-          <a:ln xmlns:a="http://schemas.openxmlformats.org/drawingml/2006/main" w="0">
-            <a:noFill/>
-            <a:prstDash val="solid"/>
-          </a:ln>
-        </p:spPr>
-        <p:txBody>
-          <a:bodyPr xmlns:a="http://schemas.openxmlformats.org/drawingml/2006/main" wrap="square" lIns="0" tIns="0" rIns="0" bIns="0" anchor="t">
-            <a:noAutofit/>
-          </a:bodyPr>
-          <a:lstStyle xmlns:a="http://schemas.openxmlformats.org/drawingml/2006/main">
-            <a:defPPr algn="l">
-              <a:defRPr sz="1275" b="0">
-                <a:solidFill>
-                  <a:srgbClr val="595959"/>
-                </a:solidFill>
-                <a:latin typeface="Arial"/>
-                <a:ea typeface="Arial"/>
-                <a:cs typeface="Arial"/>
-              </a:defRPr>
-            </a:defPPr>
-            <a:lvl1pPr algn="l">
-              <a:defRPr sz="1275" b="0">
-                <a:solidFill>
-                  <a:srgbClr val="595959"/>
-                </a:solidFill>
-                <a:latin typeface="Arial"/>
-                <a:ea typeface="Arial"/>
-                <a:cs typeface="Arial"/>
-              </a:defRPr>
-            </a:lvl1pPr>
-            <a:lvl2pPr algn="l">
-              <a:defRPr sz="1275" b="0">
-                <a:solidFill>
-                  <a:srgbClr val="595959"/>
-                </a:solidFill>
-                <a:latin typeface="Arial"/>
-                <a:ea typeface="Arial"/>
-                <a:cs typeface="Arial"/>
-              </a:defRPr>
-            </a:lvl2pPr>
-            <a:lvl3pPr algn="l">
-              <a:defRPr sz="1275" b="0">
-                <a:solidFill>
-                  <a:srgbClr val="595959"/>
-                </a:solidFill>
-                <a:latin typeface="Arial"/>
-                <a:ea typeface="Arial"/>
-                <a:cs typeface="Arial"/>
-              </a:defRPr>
-            </a:lvl3pPr>
-            <a:lvl4pPr algn="l">
-              <a:defRPr sz="1275" b="0">
-                <a:solidFill>
-                  <a:srgbClr val="595959"/>
-                </a:solidFill>
-                <a:latin typeface="Arial"/>
-                <a:ea typeface="Arial"/>
-                <a:cs typeface="Arial"/>
-              </a:defRPr>
-            </a:lvl4pPr>
-            <a:lvl5pPr algn="l">
-              <a:defRPr sz="1275" b="0">
-                <a:solidFill>
-                  <a:srgbClr val="595959"/>
-                </a:solidFill>
-                <a:latin typeface="Arial"/>
-                <a:ea typeface="Arial"/>
-                <a:cs typeface="Arial"/>
-              </a:defRPr>
-            </a:lvl5pPr>
-            <a:lvl6pPr algn="l">
-              <a:defRPr sz="1275" b="0">
-                <a:solidFill>
-                  <a:srgbClr val="595959"/>
-                </a:solidFill>
-                <a:latin typeface="Arial"/>
-                <a:ea typeface="Arial"/>
-                <a:cs typeface="Arial"/>
-              </a:defRPr>
-            </a:lvl6pPr>
-            <a:lvl7pPr algn="l">
-              <a:defRPr sz="1275" b="0">
-                <a:solidFill>
-                  <a:srgbClr val="595959"/>
-                </a:solidFill>
-                <a:latin typeface="Arial"/>
-                <a:ea typeface="Arial"/>
-                <a:cs typeface="Arial"/>
-              </a:defRPr>
-            </a:lvl7pPr>
-            <a:lvl8pPr algn="l">
-              <a:defRPr sz="1275" b="0">
-                <a:solidFill>
-                  <a:srgbClr val="595959"/>
-                </a:solidFill>
-                <a:latin typeface="Arial"/>
-                <a:ea typeface="Arial"/>
-                <a:cs typeface="Arial"/>
-              </a:defRPr>
-            </a:lvl8pPr>
-            <a:lvl9pPr algn="l">
-              <a:defRPr sz="1275" b="0">
-                <a:solidFill>
-                  <a:srgbClr val="595959"/>
-                </a:solidFill>
-                <a:latin typeface="Arial"/>
-                <a:ea typeface="Arial"/>
-                <a:cs typeface="Arial"/>
-              </a:defRPr>
-            </a:lvl9pPr>
-          </a:lstStyle>
-          <a:p xmlns:a="http://schemas.openxmlformats.org/drawingml/2006/main">
-            <a:pPr algn="l">
-              <a:defRPr sz="1275" b="0">
-                <a:solidFill>
-                  <a:srgbClr val="595959"/>
-                </a:solidFill>
-                <a:latin typeface="Arial"/>
-                <a:ea typeface="Arial"/>
-                <a:cs typeface="Arial"/>
-              </a:defRPr>
-            </a:pPr>
-            <a:r>
-              <a:rPr sz="1275" b="0">
-                <a:solidFill>
-                  <a:srgbClr val="595959"/>
-                </a:solidFill>
-                <a:latin typeface="Arial"/>
-                <a:ea typeface="Arial"/>
-                <a:cs typeface="Arial"/>
-              </a:rPr>
-              <a:t>HR публикует редакцию   ·   Сотрудник сравнивает и отвечает   ·   Руководитель видит, кто ознакомился</a:t>
-            </a:r>
           </a:p>
         </p:txBody>
       </p:sp>
     </p:spTree>
     <p:extLst>
       <p:ext uri="{BB962C8B-B14F-4D97-AF65-F5344CB8AC3E}">
-        <p14:creationId xmlns:p14="http://schemas.microsoft.com/office/powerpoint/2010/main" val="440310670"/>
+        <p14:creationId xmlns:p14="http://schemas.microsoft.com/office/powerpoint/2010/main" val="921562553"/>
       </p:ext>
     </p:extLst>
   </p:cSld>

</xml_diff>

<commit_message>
docs: enlarge presentation demo title
</commit_message>
<xml_diff>
--- a/deliverables/JanaMen_DigitalHR_Hackathon_2026_team37_3slides.pptx
+++ b/deliverables/JanaMen_DigitalHR_Hackathon_2026_team37_3slides.pptx
@@ -2,15 +2,15 @@
 <file path=ppt/presentation.xml><?xml version="1.0" encoding="utf-8"?>
 <p:presentation xmlns:p="http://schemas.openxmlformats.org/presentationml/2006/main">
   <p:sldMasterIdLst>
-    <p:sldMasterId xmlns:r="http://schemas.openxmlformats.org/officeDocument/2006/relationships" id="2147483648" r:id="R9ab49f9ee3d545f7"/>
+    <p:sldMasterId xmlns:r="http://schemas.openxmlformats.org/officeDocument/2006/relationships" id="2147483648" r:id="R1d8e4e92eecf4726"/>
   </p:sldMasterIdLst>
   <p:notesMasterIdLst>
-    <p:notesMasterId xmlns:r="http://schemas.openxmlformats.org/officeDocument/2006/relationships" r:id="R0b56a0bedb864e7b"/>
+    <p:notesMasterId xmlns:r="http://schemas.openxmlformats.org/officeDocument/2006/relationships" r:id="R1d82be695b444a4a"/>
   </p:notesMasterIdLst>
   <p:sldIdLst>
-    <p:sldId xmlns:r="http://schemas.openxmlformats.org/officeDocument/2006/relationships" id="256" r:id="R8982235e094e4be3"/>
-    <p:sldId xmlns:r="http://schemas.openxmlformats.org/officeDocument/2006/relationships" id="257" r:id="R3be493eedc364a77"/>
-    <p:sldId xmlns:r="http://schemas.openxmlformats.org/officeDocument/2006/relationships" id="258" r:id="R5ed43c70565446d7"/>
+    <p:sldId xmlns:r="http://schemas.openxmlformats.org/officeDocument/2006/relationships" id="256" r:id="R582edc9a7d7d4571"/>
+    <p:sldId xmlns:r="http://schemas.openxmlformats.org/officeDocument/2006/relationships" id="257" r:id="Ra963f16a8a364eda"/>
+    <p:sldId xmlns:r="http://schemas.openxmlformats.org/officeDocument/2006/relationships" id="258" r:id="R3b45148c027f4c6b"/>
   </p:sldIdLst>
   <p:sldSz cx="9144000" cy="5143500"/>
   <p:notesSz cx="6858000" cy="9144000"/>
@@ -926,7 +926,7 @@
           <p:cNvPr id="10" name="Google Shape;10;p5">
             <a:extLst xmlns:a="http://schemas.openxmlformats.org/drawingml/2006/main">
               <a:ext uri="{FF2B5EF4-FFF2-40B4-BE49-F238E27FC236}">
-                <a16:creationId xmlns:a16="http://schemas.microsoft.com/office/drawing/2014/main" id="{7D9E3097-F1CE-4320-8B92-2F1617630A05}"/>
+                <a16:creationId xmlns:a16="http://schemas.microsoft.com/office/drawing/2014/main" id="{1A6B4055-473C-4D47-9DF9-1E44D7AEC1A5}"/>
               </a:ext>
             </a:extLst>
           </p:cNvPr>
@@ -1090,7 +1090,7 @@
           <p:cNvPr id="11" name="Google Shape;11;p5">
             <a:extLst xmlns:a="http://schemas.openxmlformats.org/drawingml/2006/main">
               <a:ext uri="{FF2B5EF4-FFF2-40B4-BE49-F238E27FC236}">
-                <a16:creationId xmlns:a16="http://schemas.microsoft.com/office/drawing/2014/main" id="{504048B8-978B-440F-98F6-B75AC3E665A0}"/>
+                <a16:creationId xmlns:a16="http://schemas.microsoft.com/office/drawing/2014/main" id="{8A081347-F8C8-4D66-B054-301E4670C985}"/>
               </a:ext>
             </a:extLst>
           </p:cNvPr>
@@ -1254,7 +1254,7 @@
           <p:cNvPr id="12" name="Google Shape;12;p5">
             <a:extLst xmlns:a="http://schemas.openxmlformats.org/drawingml/2006/main">
               <a:ext uri="{FF2B5EF4-FFF2-40B4-BE49-F238E27FC236}">
-                <a16:creationId xmlns:a16="http://schemas.microsoft.com/office/drawing/2014/main" id="{962897C0-5B56-4F7A-B9AA-643E638104A9}"/>
+                <a16:creationId xmlns:a16="http://schemas.microsoft.com/office/drawing/2014/main" id="{7DFA356F-14FA-43CD-864F-47E6AED43DA1}"/>
               </a:ext>
             </a:extLst>
           </p:cNvPr>
@@ -1548,7 +1548,7 @@
           <p:cNvPr id="45" name="Google Shape;45;p14">
             <a:extLst xmlns:a="http://schemas.openxmlformats.org/drawingml/2006/main">
               <a:ext uri="{FF2B5EF4-FFF2-40B4-BE49-F238E27FC236}">
-                <a16:creationId xmlns:a16="http://schemas.microsoft.com/office/drawing/2014/main" id="{C08BD327-A852-4D2F-924A-FE3A82F9C771}"/>
+                <a16:creationId xmlns:a16="http://schemas.microsoft.com/office/drawing/2014/main" id="{82A8381A-2724-4A5D-BC09-F671DEF1E0A3}"/>
               </a:ext>
             </a:extLst>
           </p:cNvPr>
@@ -1716,7 +1716,7 @@
           <p:cNvPr id="46" name="Google Shape;46;p14">
             <a:extLst xmlns:a="http://schemas.openxmlformats.org/drawingml/2006/main">
               <a:ext uri="{FF2B5EF4-FFF2-40B4-BE49-F238E27FC236}">
-                <a16:creationId xmlns:a16="http://schemas.microsoft.com/office/drawing/2014/main" id="{52DAAEB0-76B1-4824-9E9A-CB339445958E}"/>
+                <a16:creationId xmlns:a16="http://schemas.microsoft.com/office/drawing/2014/main" id="{A19CDD66-7075-451F-A83C-D4BDCF7C33CC}"/>
               </a:ext>
             </a:extLst>
           </p:cNvPr>
@@ -1880,7 +1880,7 @@
           <p:cNvPr id="47" name="Google Shape;47;p14">
             <a:extLst xmlns:a="http://schemas.openxmlformats.org/drawingml/2006/main">
               <a:ext uri="{FF2B5EF4-FFF2-40B4-BE49-F238E27FC236}">
-                <a16:creationId xmlns:a16="http://schemas.microsoft.com/office/drawing/2014/main" id="{2CF601F9-DB14-47A5-850F-3BE2F3A9C1AD}"/>
+                <a16:creationId xmlns:a16="http://schemas.microsoft.com/office/drawing/2014/main" id="{BC359A3C-86B6-45C5-BED6-CC3B99399C1A}"/>
               </a:ext>
             </a:extLst>
           </p:cNvPr>
@@ -2174,7 +2174,7 @@
           <p:cNvPr id="49" name="Google Shape;49;p15">
             <a:extLst xmlns:a="http://schemas.openxmlformats.org/drawingml/2006/main">
               <a:ext uri="{FF2B5EF4-FFF2-40B4-BE49-F238E27FC236}">
-                <a16:creationId xmlns:a16="http://schemas.microsoft.com/office/drawing/2014/main" id="{D4DDFDC8-ACD4-4644-9819-B469FB7276F7}"/>
+                <a16:creationId xmlns:a16="http://schemas.microsoft.com/office/drawing/2014/main" id="{10F9BFFF-BB1A-4271-BA40-725770762EC5}"/>
               </a:ext>
             </a:extLst>
           </p:cNvPr>
@@ -2468,7 +2468,7 @@
           <p:cNvPr id="14" name="Google Shape;14;p6">
             <a:extLst xmlns:a="http://schemas.openxmlformats.org/drawingml/2006/main">
               <a:ext uri="{FF2B5EF4-FFF2-40B4-BE49-F238E27FC236}">
-                <a16:creationId xmlns:a16="http://schemas.microsoft.com/office/drawing/2014/main" id="{B7EEF452-72EB-461D-8E6B-34728289D00C}"/>
+                <a16:creationId xmlns:a16="http://schemas.microsoft.com/office/drawing/2014/main" id="{E2F06177-D55E-4DA8-9DE8-A110CCF24DC9}"/>
               </a:ext>
             </a:extLst>
           </p:cNvPr>
@@ -2632,7 +2632,7 @@
           <p:cNvPr id="15" name="Google Shape;15;p6">
             <a:extLst xmlns:a="http://schemas.openxmlformats.org/drawingml/2006/main">
               <a:ext uri="{FF2B5EF4-FFF2-40B4-BE49-F238E27FC236}">
-                <a16:creationId xmlns:a16="http://schemas.microsoft.com/office/drawing/2014/main" id="{0EC322C3-B515-4CD9-AE19-BDE52EB0648A}"/>
+                <a16:creationId xmlns:a16="http://schemas.microsoft.com/office/drawing/2014/main" id="{3D56607D-96DB-4DFB-BF00-70D74F5B4342}"/>
               </a:ext>
             </a:extLst>
           </p:cNvPr>
@@ -2796,7 +2796,7 @@
           <p:cNvPr id="16" name="Google Shape;16;p6">
             <a:extLst xmlns:a="http://schemas.openxmlformats.org/drawingml/2006/main">
               <a:ext uri="{FF2B5EF4-FFF2-40B4-BE49-F238E27FC236}">
-                <a16:creationId xmlns:a16="http://schemas.microsoft.com/office/drawing/2014/main" id="{7EDFC614-FECE-4527-916B-3F56F79843E9}"/>
+                <a16:creationId xmlns:a16="http://schemas.microsoft.com/office/drawing/2014/main" id="{48EDAAFD-4458-40CC-97FE-134541DD7869}"/>
               </a:ext>
             </a:extLst>
           </p:cNvPr>
@@ -3090,7 +3090,7 @@
           <p:cNvPr id="18" name="Google Shape;18;p7">
             <a:extLst xmlns:a="http://schemas.openxmlformats.org/drawingml/2006/main">
               <a:ext uri="{FF2B5EF4-FFF2-40B4-BE49-F238E27FC236}">
-                <a16:creationId xmlns:a16="http://schemas.microsoft.com/office/drawing/2014/main" id="{F3AADD98-A230-411A-87FD-8A5413EC7BF7}"/>
+                <a16:creationId xmlns:a16="http://schemas.microsoft.com/office/drawing/2014/main" id="{4BA104FC-01A9-4B7E-8120-B80ECA2B5007}"/>
               </a:ext>
             </a:extLst>
           </p:cNvPr>
@@ -3254,7 +3254,7 @@
           <p:cNvPr id="19" name="Google Shape;19;p7">
             <a:extLst xmlns:a="http://schemas.openxmlformats.org/drawingml/2006/main">
               <a:ext uri="{FF2B5EF4-FFF2-40B4-BE49-F238E27FC236}">
-                <a16:creationId xmlns:a16="http://schemas.microsoft.com/office/drawing/2014/main" id="{8CDC5D62-CD68-4F30-8500-02BEAC465A99}"/>
+                <a16:creationId xmlns:a16="http://schemas.microsoft.com/office/drawing/2014/main" id="{5107DFC3-041E-40C7-BBCB-273E946206D4}"/>
               </a:ext>
             </a:extLst>
           </p:cNvPr>
@@ -3548,7 +3548,7 @@
           <p:cNvPr id="21" name="Google Shape;21;p8">
             <a:extLst xmlns:a="http://schemas.openxmlformats.org/drawingml/2006/main">
               <a:ext uri="{FF2B5EF4-FFF2-40B4-BE49-F238E27FC236}">
-                <a16:creationId xmlns:a16="http://schemas.microsoft.com/office/drawing/2014/main" id="{A4F4CD16-D137-4069-8008-DC83DD3D7051}"/>
+                <a16:creationId xmlns:a16="http://schemas.microsoft.com/office/drawing/2014/main" id="{3C03C821-358B-4EA0-9DED-AC891D91C8EC}"/>
               </a:ext>
             </a:extLst>
           </p:cNvPr>
@@ -3712,7 +3712,7 @@
           <p:cNvPr id="22" name="Google Shape;22;p8">
             <a:extLst xmlns:a="http://schemas.openxmlformats.org/drawingml/2006/main">
               <a:ext uri="{FF2B5EF4-FFF2-40B4-BE49-F238E27FC236}">
-                <a16:creationId xmlns:a16="http://schemas.microsoft.com/office/drawing/2014/main" id="{2DD1336A-3EA2-44F2-B69E-CD0F8A0286E1}"/>
+                <a16:creationId xmlns:a16="http://schemas.microsoft.com/office/drawing/2014/main" id="{26815CE2-4F97-4F4B-B501-EBF7C71F6FF4}"/>
               </a:ext>
             </a:extLst>
           </p:cNvPr>
@@ -3876,7 +3876,7 @@
           <p:cNvPr id="23" name="Google Shape;23;p8">
             <a:extLst xmlns:a="http://schemas.openxmlformats.org/drawingml/2006/main">
               <a:ext uri="{FF2B5EF4-FFF2-40B4-BE49-F238E27FC236}">
-                <a16:creationId xmlns:a16="http://schemas.microsoft.com/office/drawing/2014/main" id="{0C344E75-D553-467B-A2FF-222932D677FD}"/>
+                <a16:creationId xmlns:a16="http://schemas.microsoft.com/office/drawing/2014/main" id="{A66E3FFC-75BC-4E98-A75D-69E1DFB46EE8}"/>
               </a:ext>
             </a:extLst>
           </p:cNvPr>
@@ -4040,7 +4040,7 @@
           <p:cNvPr id="24" name="Google Shape;24;p8">
             <a:extLst xmlns:a="http://schemas.openxmlformats.org/drawingml/2006/main">
               <a:ext uri="{FF2B5EF4-FFF2-40B4-BE49-F238E27FC236}">
-                <a16:creationId xmlns:a16="http://schemas.microsoft.com/office/drawing/2014/main" id="{764AC636-AD52-4EB8-BED6-7BED3803F1D1}"/>
+                <a16:creationId xmlns:a16="http://schemas.microsoft.com/office/drawing/2014/main" id="{4ACAE5EC-5CEE-4856-B056-EBEDB28869B0}"/>
               </a:ext>
             </a:extLst>
           </p:cNvPr>
@@ -4334,7 +4334,7 @@
           <p:cNvPr id="26" name="Google Shape;26;p9">
             <a:extLst xmlns:a="http://schemas.openxmlformats.org/drawingml/2006/main">
               <a:ext uri="{FF2B5EF4-FFF2-40B4-BE49-F238E27FC236}">
-                <a16:creationId xmlns:a16="http://schemas.microsoft.com/office/drawing/2014/main" id="{84354EC5-8B1B-42AF-B8D7-9037D84B6968}"/>
+                <a16:creationId xmlns:a16="http://schemas.microsoft.com/office/drawing/2014/main" id="{BDDE837A-7945-45E2-98B1-951405B728AD}"/>
               </a:ext>
             </a:extLst>
           </p:cNvPr>
@@ -4498,7 +4498,7 @@
           <p:cNvPr id="27" name="Google Shape;27;p9">
             <a:extLst xmlns:a="http://schemas.openxmlformats.org/drawingml/2006/main">
               <a:ext uri="{FF2B5EF4-FFF2-40B4-BE49-F238E27FC236}">
-                <a16:creationId xmlns:a16="http://schemas.microsoft.com/office/drawing/2014/main" id="{8032788F-1427-4446-98A6-9601F13F3B8E}"/>
+                <a16:creationId xmlns:a16="http://schemas.microsoft.com/office/drawing/2014/main" id="{D3422D67-02A5-4E5A-849F-A4E0A7E884DA}"/>
               </a:ext>
             </a:extLst>
           </p:cNvPr>
@@ -4792,7 +4792,7 @@
           <p:cNvPr id="29" name="Google Shape;29;p10">
             <a:extLst xmlns:a="http://schemas.openxmlformats.org/drawingml/2006/main">
               <a:ext uri="{FF2B5EF4-FFF2-40B4-BE49-F238E27FC236}">
-                <a16:creationId xmlns:a16="http://schemas.microsoft.com/office/drawing/2014/main" id="{EA9A1B22-C572-4797-96E5-383A3762CF74}"/>
+                <a16:creationId xmlns:a16="http://schemas.microsoft.com/office/drawing/2014/main" id="{51BA65A7-EFA2-4279-9575-AC8715309E32}"/>
               </a:ext>
             </a:extLst>
           </p:cNvPr>
@@ -4956,7 +4956,7 @@
           <p:cNvPr id="30" name="Google Shape;30;p10">
             <a:extLst xmlns:a="http://schemas.openxmlformats.org/drawingml/2006/main">
               <a:ext uri="{FF2B5EF4-FFF2-40B4-BE49-F238E27FC236}">
-                <a16:creationId xmlns:a16="http://schemas.microsoft.com/office/drawing/2014/main" id="{52661EE5-8731-4D93-9097-1970BEAFAD4D}"/>
+                <a16:creationId xmlns:a16="http://schemas.microsoft.com/office/drawing/2014/main" id="{AC454C41-F5D0-4E04-9DAF-794FD653ECD0}"/>
               </a:ext>
             </a:extLst>
           </p:cNvPr>
@@ -5120,7 +5120,7 @@
           <p:cNvPr id="31" name="Google Shape;31;p10">
             <a:extLst xmlns:a="http://schemas.openxmlformats.org/drawingml/2006/main">
               <a:ext uri="{FF2B5EF4-FFF2-40B4-BE49-F238E27FC236}">
-                <a16:creationId xmlns:a16="http://schemas.microsoft.com/office/drawing/2014/main" id="{D1DBA6A7-E821-49FE-BA94-064BB34FF2BD}"/>
+                <a16:creationId xmlns:a16="http://schemas.microsoft.com/office/drawing/2014/main" id="{BD7B4255-D59E-4A2D-9E6B-3A9A6977A5EB}"/>
               </a:ext>
             </a:extLst>
           </p:cNvPr>
@@ -5414,7 +5414,7 @@
           <p:cNvPr id="33" name="Google Shape;33;p11">
             <a:extLst xmlns:a="http://schemas.openxmlformats.org/drawingml/2006/main">
               <a:ext uri="{FF2B5EF4-FFF2-40B4-BE49-F238E27FC236}">
-                <a16:creationId xmlns:a16="http://schemas.microsoft.com/office/drawing/2014/main" id="{88BE1956-EFF6-4FE9-9422-8EF504B07C3A}"/>
+                <a16:creationId xmlns:a16="http://schemas.microsoft.com/office/drawing/2014/main" id="{0891AD13-CEE2-4DF7-B1DB-929680A08AFD}"/>
               </a:ext>
             </a:extLst>
           </p:cNvPr>
@@ -5578,7 +5578,7 @@
           <p:cNvPr id="34" name="Google Shape;34;p11">
             <a:extLst xmlns:a="http://schemas.openxmlformats.org/drawingml/2006/main">
               <a:ext uri="{FF2B5EF4-FFF2-40B4-BE49-F238E27FC236}">
-                <a16:creationId xmlns:a16="http://schemas.microsoft.com/office/drawing/2014/main" id="{2656A355-7457-4A0A-BA90-50AF3F72CD5C}"/>
+                <a16:creationId xmlns:a16="http://schemas.microsoft.com/office/drawing/2014/main" id="{F4D93A56-E37E-4D04-82C3-5B1F0A69975E}"/>
               </a:ext>
             </a:extLst>
           </p:cNvPr>
@@ -5872,7 +5872,7 @@
           <p:cNvPr id="36" name="Google Shape;36;p12">
             <a:extLst xmlns:a="http://schemas.openxmlformats.org/drawingml/2006/main">
               <a:ext uri="{FF2B5EF4-FFF2-40B4-BE49-F238E27FC236}">
-                <a16:creationId xmlns:a16="http://schemas.microsoft.com/office/drawing/2014/main" id="{4C517D0F-41C8-4231-8883-ABABD7F3E3D0}"/>
+                <a16:creationId xmlns:a16="http://schemas.microsoft.com/office/drawing/2014/main" id="{C8766FA1-97E6-468F-A960-188D9F7D88BD}"/>
               </a:ext>
             </a:extLst>
           </p:cNvPr>
@@ -5938,7 +5938,7 @@
           <p:cNvPr id="37" name="Google Shape;37;p12">
             <a:extLst xmlns:a="http://schemas.openxmlformats.org/drawingml/2006/main">
               <a:ext uri="{FF2B5EF4-FFF2-40B4-BE49-F238E27FC236}">
-                <a16:creationId xmlns:a16="http://schemas.microsoft.com/office/drawing/2014/main" id="{9FD29225-46DB-4DFF-B2CD-4C0784998E72}"/>
+                <a16:creationId xmlns:a16="http://schemas.microsoft.com/office/drawing/2014/main" id="{302CEA46-988B-4988-9204-17F0AED69FBC}"/>
               </a:ext>
             </a:extLst>
           </p:cNvPr>
@@ -6102,7 +6102,7 @@
           <p:cNvPr id="38" name="Google Shape;38;p12">
             <a:extLst xmlns:a="http://schemas.openxmlformats.org/drawingml/2006/main">
               <a:ext uri="{FF2B5EF4-FFF2-40B4-BE49-F238E27FC236}">
-                <a16:creationId xmlns:a16="http://schemas.microsoft.com/office/drawing/2014/main" id="{82AC2979-827D-41D7-8A4D-CF09656896D2}"/>
+                <a16:creationId xmlns:a16="http://schemas.microsoft.com/office/drawing/2014/main" id="{135A669A-86CC-4733-AD26-D76C8B489FDE}"/>
               </a:ext>
             </a:extLst>
           </p:cNvPr>
@@ -6266,7 +6266,7 @@
           <p:cNvPr id="39" name="Google Shape;39;p12">
             <a:extLst xmlns:a="http://schemas.openxmlformats.org/drawingml/2006/main">
               <a:ext uri="{FF2B5EF4-FFF2-40B4-BE49-F238E27FC236}">
-                <a16:creationId xmlns:a16="http://schemas.microsoft.com/office/drawing/2014/main" id="{268CF97B-CD59-4BE8-8499-D242A0440220}"/>
+                <a16:creationId xmlns:a16="http://schemas.microsoft.com/office/drawing/2014/main" id="{FE4DDDC8-3110-4011-A7A6-ED30152E5D60}"/>
               </a:ext>
             </a:extLst>
           </p:cNvPr>
@@ -6430,7 +6430,7 @@
           <p:cNvPr id="40" name="Google Shape;40;p12">
             <a:extLst xmlns:a="http://schemas.openxmlformats.org/drawingml/2006/main">
               <a:ext uri="{FF2B5EF4-FFF2-40B4-BE49-F238E27FC236}">
-                <a16:creationId xmlns:a16="http://schemas.microsoft.com/office/drawing/2014/main" id="{B72EE85B-72CD-471D-A278-4BBF51131EE1}"/>
+                <a16:creationId xmlns:a16="http://schemas.microsoft.com/office/drawing/2014/main" id="{79416879-0492-40A3-AD95-BA8087C83F17}"/>
               </a:ext>
             </a:extLst>
           </p:cNvPr>
@@ -6724,7 +6724,7 @@
           <p:cNvPr id="42" name="Google Shape;42;p13">
             <a:extLst xmlns:a="http://schemas.openxmlformats.org/drawingml/2006/main">
               <a:ext uri="{FF2B5EF4-FFF2-40B4-BE49-F238E27FC236}">
-                <a16:creationId xmlns:a16="http://schemas.microsoft.com/office/drawing/2014/main" id="{A67365DF-ADA9-4ECE-8626-5C9115EBFDC7}"/>
+                <a16:creationId xmlns:a16="http://schemas.microsoft.com/office/drawing/2014/main" id="{7F048238-B122-44D4-B833-379746487D20}"/>
               </a:ext>
             </a:extLst>
           </p:cNvPr>
@@ -6776,7 +6776,7 @@
           <p:cNvPr id="43" name="Google Shape;43;p13">
             <a:extLst xmlns:a="http://schemas.openxmlformats.org/drawingml/2006/main">
               <a:ext uri="{FF2B5EF4-FFF2-40B4-BE49-F238E27FC236}">
-                <a16:creationId xmlns:a16="http://schemas.microsoft.com/office/drawing/2014/main" id="{B0161CCB-94B2-4DD8-AF5E-62A759BCC7BA}"/>
+                <a16:creationId xmlns:a16="http://schemas.microsoft.com/office/drawing/2014/main" id="{56B5797E-D565-4480-830D-0D7B935246E3}"/>
               </a:ext>
             </a:extLst>
           </p:cNvPr>
@@ -7077,7 +7077,7 @@
           <p:cNvPr id="6" name="Google Shape;6;p4">
             <a:extLst xmlns:a="http://schemas.openxmlformats.org/drawingml/2006/main">
               <a:ext uri="{FF2B5EF4-FFF2-40B4-BE49-F238E27FC236}">
-                <a16:creationId xmlns:a16="http://schemas.microsoft.com/office/drawing/2014/main" id="{E4D9C3ED-0A2A-4986-9D2E-7FF1A5BCB5D0}"/>
+                <a16:creationId xmlns:a16="http://schemas.microsoft.com/office/drawing/2014/main" id="{9A6223F0-4AD6-4537-B27B-F8BDAF05861F}"/>
               </a:ext>
             </a:extLst>
           </p:cNvPr>
@@ -7340,7 +7340,7 @@
           <p:cNvPr id="7" name="Google Shape;7;p4">
             <a:extLst xmlns:a="http://schemas.openxmlformats.org/drawingml/2006/main">
               <a:ext uri="{FF2B5EF4-FFF2-40B4-BE49-F238E27FC236}">
-                <a16:creationId xmlns:a16="http://schemas.microsoft.com/office/drawing/2014/main" id="{8F687028-CEFB-466A-8161-9C05442066D4}"/>
+                <a16:creationId xmlns:a16="http://schemas.microsoft.com/office/drawing/2014/main" id="{BBB43F11-7A49-486C-9C16-E8A5C6EB433D}"/>
               </a:ext>
             </a:extLst>
           </p:cNvPr>
@@ -7603,7 +7603,7 @@
           <p:cNvPr id="8" name="Google Shape;8;p4">
             <a:extLst xmlns:a="http://schemas.openxmlformats.org/drawingml/2006/main">
               <a:ext uri="{FF2B5EF4-FFF2-40B4-BE49-F238E27FC236}">
-                <a16:creationId xmlns:a16="http://schemas.microsoft.com/office/drawing/2014/main" id="{A9FBDBB1-C3DA-4444-9EB6-6FD19C466C36}"/>
+                <a16:creationId xmlns:a16="http://schemas.microsoft.com/office/drawing/2014/main" id="{C18BFAB4-16EF-4756-9CDD-E086B8ACB09D}"/>
               </a:ext>
             </a:extLst>
           </p:cNvPr>
@@ -7879,17 +7879,17 @@
   </p:cSld>
   <p:clrMap bg1="lt1" tx1="dk1" bg2="dk2" tx2="lt2" accent1="accent1" accent2="accent2" accent3="accent3" accent4="accent4" accent5="accent5" accent6="accent6" hlink="hlink" folHlink="folHlink"/>
   <p:sldLayoutIdLst>
-    <p:sldLayoutId xmlns:r="http://schemas.openxmlformats.org/officeDocument/2006/relationships" id="2147483649" r:id="R5aa8032de97a49c8"/>
-    <p:sldLayoutId xmlns:r="http://schemas.openxmlformats.org/officeDocument/2006/relationships" id="2147483650" r:id="Rc401e25e46dc4af7"/>
-    <p:sldLayoutId xmlns:r="http://schemas.openxmlformats.org/officeDocument/2006/relationships" id="2147483651" r:id="R76ea84a0ab874f48"/>
-    <p:sldLayoutId xmlns:r="http://schemas.openxmlformats.org/officeDocument/2006/relationships" id="2147483652" r:id="Re51e19edea7f4cb7"/>
-    <p:sldLayoutId xmlns:r="http://schemas.openxmlformats.org/officeDocument/2006/relationships" id="2147483653" r:id="R1442ef2aa53248d5"/>
-    <p:sldLayoutId xmlns:r="http://schemas.openxmlformats.org/officeDocument/2006/relationships" id="2147483654" r:id="R52bb9c63f40d4c4f"/>
-    <p:sldLayoutId xmlns:r="http://schemas.openxmlformats.org/officeDocument/2006/relationships" id="2147483655" r:id="Rb3f4bcaf6c0c4fd2"/>
-    <p:sldLayoutId xmlns:r="http://schemas.openxmlformats.org/officeDocument/2006/relationships" id="2147483656" r:id="Rf0d88fc4ae6a4bb0"/>
-    <p:sldLayoutId xmlns:r="http://schemas.openxmlformats.org/officeDocument/2006/relationships" id="2147483657" r:id="R9abbdb2897bf4485"/>
-    <p:sldLayoutId xmlns:r="http://schemas.openxmlformats.org/officeDocument/2006/relationships" id="2147483658" r:id="R45b1d14b0dc84469"/>
-    <p:sldLayoutId xmlns:r="http://schemas.openxmlformats.org/officeDocument/2006/relationships" id="2147483659" r:id="R327d1cdf1f554c96"/>
+    <p:sldLayoutId xmlns:r="http://schemas.openxmlformats.org/officeDocument/2006/relationships" id="2147483649" r:id="R1c5bf065715a4935"/>
+    <p:sldLayoutId xmlns:r="http://schemas.openxmlformats.org/officeDocument/2006/relationships" id="2147483650" r:id="R0c00ef121ac8456d"/>
+    <p:sldLayoutId xmlns:r="http://schemas.openxmlformats.org/officeDocument/2006/relationships" id="2147483651" r:id="R7911e6274f5c47cb"/>
+    <p:sldLayoutId xmlns:r="http://schemas.openxmlformats.org/officeDocument/2006/relationships" id="2147483652" r:id="R262433eef2314cc6"/>
+    <p:sldLayoutId xmlns:r="http://schemas.openxmlformats.org/officeDocument/2006/relationships" id="2147483653" r:id="R7b11384f5583466d"/>
+    <p:sldLayoutId xmlns:r="http://schemas.openxmlformats.org/officeDocument/2006/relationships" id="2147483654" r:id="Rcd4d50c141444e1e"/>
+    <p:sldLayoutId xmlns:r="http://schemas.openxmlformats.org/officeDocument/2006/relationships" id="2147483655" r:id="R2e59e1b64e8940fb"/>
+    <p:sldLayoutId xmlns:r="http://schemas.openxmlformats.org/officeDocument/2006/relationships" id="2147483656" r:id="R21db46e2db7446a4"/>
+    <p:sldLayoutId xmlns:r="http://schemas.openxmlformats.org/officeDocument/2006/relationships" id="2147483657" r:id="R249ede650c36433a"/>
+    <p:sldLayoutId xmlns:r="http://schemas.openxmlformats.org/officeDocument/2006/relationships" id="2147483658" r:id="R472ba3dbe9ed44a4"/>
+    <p:sldLayoutId xmlns:r="http://schemas.openxmlformats.org/officeDocument/2006/relationships" id="2147483659" r:id="Ra645bbeaf6564636"/>
   </p:sldLayoutIdLst>
   <p:hf sldNum="0" hdr="0" ftr="0" dt="0"/>
   <p:txStyles>
@@ -8836,7 +8836,7 @@
           <p:cNvPr id="54" name="Google Shape;54;p1">
             <a:extLst xmlns:a="http://schemas.openxmlformats.org/drawingml/2006/main">
               <a:ext uri="{FF2B5EF4-FFF2-40B4-BE49-F238E27FC236}">
-                <a16:creationId xmlns:a16="http://schemas.microsoft.com/office/drawing/2014/main" id="{B61DC35D-0A3D-4FCC-BD45-3F48CCBDC60C}"/>
+                <a16:creationId xmlns:a16="http://schemas.microsoft.com/office/drawing/2014/main" id="{B5324D97-1D07-471A-9CE9-AC2147C10EF5}"/>
               </a:ext>
             </a:extLst>
           </p:cNvPr>
@@ -8891,7 +8891,7 @@
           <p:cNvPr id="55" name="Google Shape;55;p1">
             <a:extLst xmlns:a="http://schemas.openxmlformats.org/drawingml/2006/main">
               <a:ext uri="{FF2B5EF4-FFF2-40B4-BE49-F238E27FC236}">
-                <a16:creationId xmlns:a16="http://schemas.microsoft.com/office/drawing/2014/main" id="{E68B809B-5D20-40C9-A0D4-90A0DF84A5F6}"/>
+                <a16:creationId xmlns:a16="http://schemas.microsoft.com/office/drawing/2014/main" id="{C8422AF3-325C-4263-8E0A-0793A2675A81}"/>
               </a:ext>
             </a:extLst>
           </p:cNvPr>
@@ -8946,7 +8946,7 @@
           <p:cNvPr id="56" name="Google Shape;56;p1">
             <a:extLst xmlns:a="http://schemas.openxmlformats.org/drawingml/2006/main">
               <a:ext uri="{FF2B5EF4-FFF2-40B4-BE49-F238E27FC236}">
-                <a16:creationId xmlns:a16="http://schemas.microsoft.com/office/drawing/2014/main" id="{C0D6C0A7-6D12-4838-AFC9-D4083FC0912B}"/>
+                <a16:creationId xmlns:a16="http://schemas.microsoft.com/office/drawing/2014/main" id="{D7C85FD7-EA17-460A-930B-78DE7F952FA9}"/>
               </a:ext>
             </a:extLst>
           </p:cNvPr>
@@ -8956,7 +8956,7 @@
           <p:nvPr/>
         </p:nvPicPr>
         <p:blipFill rotWithShape="1">
-          <a:blip xmlns:r="http://schemas.openxmlformats.org/officeDocument/2006/relationships" xmlns:a="http://schemas.openxmlformats.org/drawingml/2006/main" r:embed="R6e3921d3a5974493">
+          <a:blip xmlns:r="http://schemas.openxmlformats.org/officeDocument/2006/relationships" xmlns:a="http://schemas.openxmlformats.org/drawingml/2006/main" r:embed="Rafb687d366124982">
             <a:alphaModFix/>
           </a:blip>
           <a:srcRect xmlns:a="http://schemas.openxmlformats.org/drawingml/2006/main" l="0" t="0" r="0" b="0"/>
@@ -8980,7 +8980,7 @@
           <p:cNvPr id="57" name="Google Shape;57;p1">
             <a:extLst xmlns:a="http://schemas.openxmlformats.org/drawingml/2006/main">
               <a:ext uri="{FF2B5EF4-FFF2-40B4-BE49-F238E27FC236}">
-                <a16:creationId xmlns:a16="http://schemas.microsoft.com/office/drawing/2014/main" id="{54CB71C1-0DE8-4496-9873-D0776963C5FD}"/>
+                <a16:creationId xmlns:a16="http://schemas.microsoft.com/office/drawing/2014/main" id="{ABAACD40-6DEB-4763-A335-52D8A0B0C1C5}"/>
               </a:ext>
             </a:extLst>
           </p:cNvPr>
@@ -9050,7 +9050,7 @@
     </p:spTree>
     <p:extLst>
       <p:ext uri="{BB962C8B-B14F-4D97-AF65-F5344CB8AC3E}">
-        <p14:creationId xmlns:p14="http://schemas.microsoft.com/office/powerpoint/2010/main" val="2051488737"/>
+        <p14:creationId xmlns:p14="http://schemas.microsoft.com/office/powerpoint/2010/main" val="1111880050"/>
       </p:ext>
     </p:extLst>
   </p:cSld>
@@ -9074,7 +9074,7 @@
           <p:cNvPr id="62" name="Google Shape;62;p2">
             <a:extLst xmlns:a="http://schemas.openxmlformats.org/drawingml/2006/main">
               <a:ext uri="{FF2B5EF4-FFF2-40B4-BE49-F238E27FC236}">
-                <a16:creationId xmlns:a16="http://schemas.microsoft.com/office/drawing/2014/main" id="{C9679614-3EF2-4DF4-91F3-017CD969A9FB}"/>
+                <a16:creationId xmlns:a16="http://schemas.microsoft.com/office/drawing/2014/main" id="{2C11A4F6-FC1B-4A7C-A6C3-C0DFD5302D66}"/>
               </a:ext>
             </a:extLst>
           </p:cNvPr>
@@ -9129,7 +9129,7 @@
           <p:cNvPr id="63" name="overview lead">
             <a:extLst xmlns:a="http://schemas.openxmlformats.org/drawingml/2006/main">
               <a:ext uri="{FF2B5EF4-FFF2-40B4-BE49-F238E27FC236}">
-                <a16:creationId xmlns:a16="http://schemas.microsoft.com/office/drawing/2014/main" id="{49BF73FF-FC88-484B-90A5-15592EC06B40}"/>
+                <a16:creationId xmlns:a16="http://schemas.microsoft.com/office/drawing/2014/main" id="{6E2D7055-DAD9-433F-9CCA-98C2453A9768}"/>
               </a:ext>
             </a:extLst>
           </p:cNvPr>
@@ -9288,7 +9288,7 @@
           <p:cNvPr id="64" name="overview heading 1">
             <a:extLst xmlns:a="http://schemas.openxmlformats.org/drawingml/2006/main">
               <a:ext uri="{FF2B5EF4-FFF2-40B4-BE49-F238E27FC236}">
-                <a16:creationId xmlns:a16="http://schemas.microsoft.com/office/drawing/2014/main" id="{3749DBEC-D052-46F1-BBFF-B3D990301703}"/>
+                <a16:creationId xmlns:a16="http://schemas.microsoft.com/office/drawing/2014/main" id="{C5904252-900E-4E09-87AE-F65B2F47D45F}"/>
               </a:ext>
             </a:extLst>
           </p:cNvPr>
@@ -9447,7 +9447,7 @@
           <p:cNvPr id="65" name="overview detail 1">
             <a:extLst xmlns:a="http://schemas.openxmlformats.org/drawingml/2006/main">
               <a:ext uri="{FF2B5EF4-FFF2-40B4-BE49-F238E27FC236}">
-                <a16:creationId xmlns:a16="http://schemas.microsoft.com/office/drawing/2014/main" id="{3B88B743-9C5E-47C2-9869-173A77013CF6}"/>
+                <a16:creationId xmlns:a16="http://schemas.microsoft.com/office/drawing/2014/main" id="{E4F39484-1B98-4DEA-8792-2775D81CDA45}"/>
               </a:ext>
             </a:extLst>
           </p:cNvPr>
@@ -9606,7 +9606,7 @@
           <p:cNvPr id="66" name="overview heading 2">
             <a:extLst xmlns:a="http://schemas.openxmlformats.org/drawingml/2006/main">
               <a:ext uri="{FF2B5EF4-FFF2-40B4-BE49-F238E27FC236}">
-                <a16:creationId xmlns:a16="http://schemas.microsoft.com/office/drawing/2014/main" id="{1097F577-859F-44CF-853F-90F4646EB5D9}"/>
+                <a16:creationId xmlns:a16="http://schemas.microsoft.com/office/drawing/2014/main" id="{2E09D91A-9698-40B9-8F65-74FAD485AA5E}"/>
               </a:ext>
             </a:extLst>
           </p:cNvPr>
@@ -9765,7 +9765,7 @@
           <p:cNvPr id="67" name="overview detail 2">
             <a:extLst xmlns:a="http://schemas.openxmlformats.org/drawingml/2006/main">
               <a:ext uri="{FF2B5EF4-FFF2-40B4-BE49-F238E27FC236}">
-                <a16:creationId xmlns:a16="http://schemas.microsoft.com/office/drawing/2014/main" id="{51E58EBE-5C38-4F26-8E8D-9C1C7E5E838E}"/>
+                <a16:creationId xmlns:a16="http://schemas.microsoft.com/office/drawing/2014/main" id="{96EB472B-A91A-46DD-8F87-B5D36B32E6D3}"/>
               </a:ext>
             </a:extLst>
           </p:cNvPr>
@@ -9924,7 +9924,7 @@
           <p:cNvPr id="68" name="overview heading 3">
             <a:extLst xmlns:a="http://schemas.openxmlformats.org/drawingml/2006/main">
               <a:ext uri="{FF2B5EF4-FFF2-40B4-BE49-F238E27FC236}">
-                <a16:creationId xmlns:a16="http://schemas.microsoft.com/office/drawing/2014/main" id="{5E699ACF-7866-43DE-B5E8-7E645CE759D5}"/>
+                <a16:creationId xmlns:a16="http://schemas.microsoft.com/office/drawing/2014/main" id="{E248D1BA-DC14-48B0-9265-696418A71A8A}"/>
               </a:ext>
             </a:extLst>
           </p:cNvPr>
@@ -10083,7 +10083,7 @@
           <p:cNvPr id="69" name="overview detail 3">
             <a:extLst xmlns:a="http://schemas.openxmlformats.org/drawingml/2006/main">
               <a:ext uri="{FF2B5EF4-FFF2-40B4-BE49-F238E27FC236}">
-                <a16:creationId xmlns:a16="http://schemas.microsoft.com/office/drawing/2014/main" id="{66292ADE-D735-4C0A-A18A-703706BCDF54}"/>
+                <a16:creationId xmlns:a16="http://schemas.microsoft.com/office/drawing/2014/main" id="{C6446976-E26C-4E00-95CB-3421662C0ECE}"/>
               </a:ext>
             </a:extLst>
           </p:cNvPr>
@@ -10242,7 +10242,7 @@
           <p:cNvPr id="70" name="overview heading 4">
             <a:extLst xmlns:a="http://schemas.openxmlformats.org/drawingml/2006/main">
               <a:ext uri="{FF2B5EF4-FFF2-40B4-BE49-F238E27FC236}">
-                <a16:creationId xmlns:a16="http://schemas.microsoft.com/office/drawing/2014/main" id="{2E77A26C-DD3F-400C-B2FB-29867D0FD4ED}"/>
+                <a16:creationId xmlns:a16="http://schemas.microsoft.com/office/drawing/2014/main" id="{1BE68ACE-3C84-4614-A98B-6FFB85F86635}"/>
               </a:ext>
             </a:extLst>
           </p:cNvPr>
@@ -10401,7 +10401,7 @@
           <p:cNvPr id="71" name="overview detail 4">
             <a:extLst xmlns:a="http://schemas.openxmlformats.org/drawingml/2006/main">
               <a:ext uri="{FF2B5EF4-FFF2-40B4-BE49-F238E27FC236}">
-                <a16:creationId xmlns:a16="http://schemas.microsoft.com/office/drawing/2014/main" id="{83BC7CBC-D803-479D-A194-B0A9BB30102C}"/>
+                <a16:creationId xmlns:a16="http://schemas.microsoft.com/office/drawing/2014/main" id="{13C64BF3-B023-4C8D-B89E-0023DC2BA017}"/>
               </a:ext>
             </a:extLst>
           </p:cNvPr>
@@ -10558,7 +10558,7 @@
     </p:spTree>
     <p:extLst>
       <p:ext uri="{BB962C8B-B14F-4D97-AF65-F5344CB8AC3E}">
-        <p14:creationId xmlns:p14="http://schemas.microsoft.com/office/powerpoint/2010/main" val="293014445"/>
+        <p14:creationId xmlns:p14="http://schemas.microsoft.com/office/powerpoint/2010/main" val="1109874696"/>
       </p:ext>
     </p:extLst>
   </p:cSld>
@@ -10582,7 +10582,7 @@
           <p:cNvPr id="68" name="Google Shape;68;p3">
             <a:extLst xmlns:a="http://schemas.openxmlformats.org/drawingml/2006/main">
               <a:ext uri="{FF2B5EF4-FFF2-40B4-BE49-F238E27FC236}">
-                <a16:creationId xmlns:a16="http://schemas.microsoft.com/office/drawing/2014/main" id="{C30CC277-D252-4B91-A848-ABB2895676B8}"/>
+                <a16:creationId xmlns:a16="http://schemas.microsoft.com/office/drawing/2014/main" id="{74ABA009-C9C4-4DCE-BC81-4A334BE58628}"/>
               </a:ext>
             </a:extLst>
           </p:cNvPr>
@@ -10607,10 +10607,111 @@
           </a:ln>
         </p:spPr>
         <p:txBody>
-          <a:bodyPr xmlns:a="http://schemas.openxmlformats.org/drawingml/2006/main" spcFirstLastPara="1" wrap="square" lIns="91425" tIns="91425" rIns="91425" bIns="91425" anchor="t">
-            <a:normAutofit fontScale="91360"/>
+          <a:bodyPr xmlns:a="http://schemas.openxmlformats.org/drawingml/2006/main" spcFirstLastPara="1" wrap="square" lIns="0" tIns="0" rIns="0" bIns="0" anchor="t">
+            <a:noAutofit/>
           </a:bodyPr>
-          <a:lstStyle xmlns:a="http://schemas.openxmlformats.org/drawingml/2006/main"/>
+          <a:lstStyle xmlns:a="http://schemas.openxmlformats.org/drawingml/2006/main">
+            <a:defPPr algn="l">
+              <a:defRPr sz="3900" b="0">
+                <a:solidFill>
+                  <a:srgbClr val="111111"/>
+                </a:solidFill>
+                <a:latin typeface="Arial"/>
+                <a:ea typeface="Arial"/>
+                <a:cs typeface="Arial"/>
+              </a:defRPr>
+            </a:defPPr>
+            <a:lvl1pPr algn="l">
+              <a:defRPr sz="3900" b="0">
+                <a:solidFill>
+                  <a:srgbClr val="111111"/>
+                </a:solidFill>
+                <a:latin typeface="Arial"/>
+                <a:ea typeface="Arial"/>
+                <a:cs typeface="Arial"/>
+              </a:defRPr>
+            </a:lvl1pPr>
+            <a:lvl2pPr algn="l">
+              <a:defRPr sz="3900" b="0">
+                <a:solidFill>
+                  <a:srgbClr val="111111"/>
+                </a:solidFill>
+                <a:latin typeface="Arial"/>
+                <a:ea typeface="Arial"/>
+                <a:cs typeface="Arial"/>
+              </a:defRPr>
+            </a:lvl2pPr>
+            <a:lvl3pPr algn="l">
+              <a:defRPr sz="3900" b="0">
+                <a:solidFill>
+                  <a:srgbClr val="111111"/>
+                </a:solidFill>
+                <a:latin typeface="Arial"/>
+                <a:ea typeface="Arial"/>
+                <a:cs typeface="Arial"/>
+              </a:defRPr>
+            </a:lvl3pPr>
+            <a:lvl4pPr algn="l">
+              <a:defRPr sz="3900" b="0">
+                <a:solidFill>
+                  <a:srgbClr val="111111"/>
+                </a:solidFill>
+                <a:latin typeface="Arial"/>
+                <a:ea typeface="Arial"/>
+                <a:cs typeface="Arial"/>
+              </a:defRPr>
+            </a:lvl4pPr>
+            <a:lvl5pPr algn="l">
+              <a:defRPr sz="3900" b="0">
+                <a:solidFill>
+                  <a:srgbClr val="111111"/>
+                </a:solidFill>
+                <a:latin typeface="Arial"/>
+                <a:ea typeface="Arial"/>
+                <a:cs typeface="Arial"/>
+              </a:defRPr>
+            </a:lvl5pPr>
+            <a:lvl6pPr algn="l">
+              <a:defRPr sz="3900" b="0">
+                <a:solidFill>
+                  <a:srgbClr val="111111"/>
+                </a:solidFill>
+                <a:latin typeface="Arial"/>
+                <a:ea typeface="Arial"/>
+                <a:cs typeface="Arial"/>
+              </a:defRPr>
+            </a:lvl6pPr>
+            <a:lvl7pPr algn="l">
+              <a:defRPr sz="3900" b="0">
+                <a:solidFill>
+                  <a:srgbClr val="111111"/>
+                </a:solidFill>
+                <a:latin typeface="Arial"/>
+                <a:ea typeface="Arial"/>
+                <a:cs typeface="Arial"/>
+              </a:defRPr>
+            </a:lvl7pPr>
+            <a:lvl8pPr algn="l">
+              <a:defRPr sz="3900" b="0">
+                <a:solidFill>
+                  <a:srgbClr val="111111"/>
+                </a:solidFill>
+                <a:latin typeface="Arial"/>
+                <a:ea typeface="Arial"/>
+                <a:cs typeface="Arial"/>
+              </a:defRPr>
+            </a:lvl8pPr>
+            <a:lvl9pPr algn="l">
+              <a:defRPr sz="3900" b="0">
+                <a:solidFill>
+                  <a:srgbClr val="111111"/>
+                </a:solidFill>
+                <a:latin typeface="Arial"/>
+                <a:ea typeface="Arial"/>
+                <a:cs typeface="Arial"/>
+              </a:defRPr>
+            </a:lvl9pPr>
+          </a:lstStyle>
           <a:p xmlns:a="http://schemas.openxmlformats.org/drawingml/2006/main">
             <a:pPr marL="0" lvl="0" indent="0" algn="l">
               <a:lnSpc>
@@ -10624,8 +10725,24 @@
               </a:spcAft>
               <a:buSzPct val="111111"/>
               <a:buNone/>
+              <a:defRPr sz="3900" b="0">
+                <a:solidFill>
+                  <a:srgbClr val="111111"/>
+                </a:solidFill>
+                <a:latin typeface="Arial"/>
+                <a:ea typeface="Arial"/>
+                <a:cs typeface="Arial"/>
+              </a:defRPr>
             </a:pPr>
             <a:r>
+              <a:rPr sz="3900" b="0">
+                <a:solidFill>
+                  <a:srgbClr val="111111"/>
+                </a:solidFill>
+                <a:latin typeface="Arial"/>
+                <a:ea typeface="Arial"/>
+                <a:cs typeface="Arial"/>
+              </a:rPr>
               <a:t>Демонстрация</a:t>
             </a:r>
             <a:endParaRPr/>
@@ -10635,7 +10752,7 @@
     </p:spTree>
     <p:extLst>
       <p:ext uri="{BB962C8B-B14F-4D97-AF65-F5344CB8AC3E}">
-        <p14:creationId xmlns:p14="http://schemas.microsoft.com/office/powerpoint/2010/main" val="921562553"/>
+        <p14:creationId xmlns:p14="http://schemas.microsoft.com/office/powerpoint/2010/main" val="1669982150"/>
       </p:ext>
     </p:extLst>
   </p:cSld>

</xml_diff>